<commit_message>
Add updated Insurance_Management_Presentation files
</commit_message>
<xml_diff>
--- a/Insurance_Management_Presentation.pptx
+++ b/Insurance_Management_Presentation.pptx
@@ -119,6 +119,11 @@
       </a:defRPr>
     </a:lvl9pPr>
   </p:defaultTextStyle>
+  <p:extLst>
+    <p:ext uri="{EFAFB233-063F-42B5-8137-9DF3F51BA10A}">
+      <p15:sldGuideLst xmlns:p15="http://schemas.microsoft.com/office/powerpoint/2012/main"/>
+    </p:ext>
+  </p:extLst>
 </p:presentation>
 </file>
 
@@ -135,7 +140,7 @@
   <pc:docChgLst>
     <pc:chgData name="Tolu Atanda" userId="aaf42d42e9a9e251" providerId="LiveId" clId="{221A5667-1878-4670-971A-4761DD081DF9}"/>
     <pc:docChg chg="undo custSel addSld modSld addMainMaster delMainMaster">
-      <pc:chgData name="Tolu Atanda" userId="aaf42d42e9a9e251" providerId="LiveId" clId="{221A5667-1878-4670-971A-4761DD081DF9}" dt="2026-05-03T13:24:47.284" v="482" actId="26606"/>
+      <pc:chgData name="Tolu Atanda" userId="aaf42d42e9a9e251" providerId="LiveId" clId="{221A5667-1878-4670-971A-4761DD081DF9}" dt="2026-05-05T20:05:10.686" v="483" actId="2711"/>
       <pc:docMkLst>
         <pc:docMk/>
       </pc:docMkLst>
@@ -159,14 +164,6 @@
             <pc:docMk/>
             <pc:sldMk cId="252880333" sldId="256"/>
             <ac:spMk id="3" creationId="{19C12066-602A-D6C5-086F-2585CFD1B7CE}"/>
-          </ac:spMkLst>
-        </pc:spChg>
-        <pc:spChg chg="add del mod">
-          <ac:chgData name="Tolu Atanda" userId="aaf42d42e9a9e251" providerId="LiveId" clId="{221A5667-1878-4670-971A-4761DD081DF9}" dt="2026-05-03T02:10:41.160" v="117" actId="26606"/>
-          <ac:spMkLst>
-            <pc:docMk/>
-            <pc:sldMk cId="252880333" sldId="256"/>
-            <ac:spMk id="8" creationId="{D0E8B02A-EB09-F9B7-5947-369B6784017A}"/>
           </ac:spMkLst>
         </pc:spChg>
       </pc:sldChg>
@@ -215,22 +212,6 @@
             <ac:spMk id="2" creationId="{682C6DDB-82B8-9426-1CAD-038C495A792C}"/>
           </ac:spMkLst>
         </pc:spChg>
-        <pc:spChg chg="del">
-          <ac:chgData name="Tolu Atanda" userId="aaf42d42e9a9e251" providerId="LiveId" clId="{221A5667-1878-4670-971A-4761DD081DF9}" dt="2026-05-03T13:10:23.333" v="390" actId="478"/>
-          <ac:spMkLst>
-            <pc:docMk/>
-            <pc:sldMk cId="3618585452" sldId="258"/>
-            <ac:spMk id="3" creationId="{BDF5C156-2610-888F-83D1-54189520DFA1}"/>
-          </ac:spMkLst>
-        </pc:spChg>
-        <pc:spChg chg="del mod">
-          <ac:chgData name="Tolu Atanda" userId="aaf42d42e9a9e251" providerId="LiveId" clId="{221A5667-1878-4670-971A-4761DD081DF9}" dt="2026-05-03T13:10:45.598" v="391" actId="26606"/>
-          <ac:spMkLst>
-            <pc:docMk/>
-            <pc:sldMk cId="3618585452" sldId="258"/>
-            <ac:spMk id="4" creationId="{24F0460A-287B-E470-586E-D8D035A57BC5}"/>
-          </ac:spMkLst>
-        </pc:spChg>
         <pc:graphicFrameChg chg="add mod">
           <ac:chgData name="Tolu Atanda" userId="aaf42d42e9a9e251" providerId="LiveId" clId="{221A5667-1878-4670-971A-4761DD081DF9}" dt="2026-05-03T13:10:45.598" v="391" actId="26606"/>
           <ac:graphicFrameMkLst>
@@ -254,14 +235,6 @@
             <ac:spMk id="2" creationId="{B2CD7A5F-CBB4-8084-5C2C-96033C8FDB0E}"/>
           </ac:spMkLst>
         </pc:spChg>
-        <pc:spChg chg="del">
-          <ac:chgData name="Tolu Atanda" userId="aaf42d42e9a9e251" providerId="LiveId" clId="{221A5667-1878-4670-971A-4761DD081DF9}" dt="2026-05-03T02:23:29.663" v="170"/>
-          <ac:spMkLst>
-            <pc:docMk/>
-            <pc:sldMk cId="1745904149" sldId="259"/>
-            <ac:spMk id="3" creationId="{FD5B6700-93BC-BFA7-3189-42008E79F7E0}"/>
-          </ac:spMkLst>
-        </pc:spChg>
         <pc:spChg chg="mod ord">
           <ac:chgData name="Tolu Atanda" userId="aaf42d42e9a9e251" providerId="LiveId" clId="{221A5667-1878-4670-971A-4761DD081DF9}" dt="2026-05-03T02:25:21.576" v="185" actId="26606"/>
           <ac:spMkLst>
@@ -270,54 +243,6 @@
             <ac:spMk id="4" creationId="{A0C658C4-1C59-3D53-AA28-C51B4D83B618}"/>
           </ac:spMkLst>
         </pc:spChg>
-        <pc:spChg chg="add del mod">
-          <ac:chgData name="Tolu Atanda" userId="aaf42d42e9a9e251" providerId="LiveId" clId="{221A5667-1878-4670-971A-4761DD081DF9}" dt="2026-05-03T02:23:49.559" v="173" actId="931"/>
-          <ac:spMkLst>
-            <pc:docMk/>
-            <pc:sldMk cId="1745904149" sldId="259"/>
-            <ac:spMk id="7" creationId="{13F9CB5B-9A5E-89A9-EA0C-AF308367E692}"/>
-          </ac:spMkLst>
-        </pc:spChg>
-        <pc:spChg chg="add del mod">
-          <ac:chgData name="Tolu Atanda" userId="aaf42d42e9a9e251" providerId="LiveId" clId="{221A5667-1878-4670-971A-4761DD081DF9}" dt="2026-05-03T02:24:51.606" v="179" actId="931"/>
-          <ac:spMkLst>
-            <pc:docMk/>
-            <pc:sldMk cId="1745904149" sldId="259"/>
-            <ac:spMk id="11" creationId="{6C28DC20-B09F-3CEF-EF25-4B4B9CFC4F82}"/>
-          </ac:spMkLst>
-        </pc:spChg>
-        <pc:spChg chg="add del mod">
-          <ac:chgData name="Tolu Atanda" userId="aaf42d42e9a9e251" providerId="LiveId" clId="{221A5667-1878-4670-971A-4761DD081DF9}" dt="2026-05-03T02:25:03.843" v="181" actId="478"/>
-          <ac:spMkLst>
-            <pc:docMk/>
-            <pc:sldMk cId="1745904149" sldId="259"/>
-            <ac:spMk id="15" creationId="{9A7ADDB9-E20A-9757-02B6-251D73A4DD11}"/>
-          </ac:spMkLst>
-        </pc:spChg>
-        <pc:picChg chg="add del mod">
-          <ac:chgData name="Tolu Atanda" userId="aaf42d42e9a9e251" providerId="LiveId" clId="{221A5667-1878-4670-971A-4761DD081DF9}" dt="2026-05-03T02:23:37.011" v="172" actId="478"/>
-          <ac:picMkLst>
-            <pc:docMk/>
-            <pc:sldMk cId="1745904149" sldId="259"/>
-            <ac:picMk id="5" creationId="{DBF12AF3-A01E-4725-DFFB-5C100D95E5EC}"/>
-          </ac:picMkLst>
-        </pc:picChg>
-        <pc:picChg chg="add del mod ord">
-          <ac:chgData name="Tolu Atanda" userId="aaf42d42e9a9e251" providerId="LiveId" clId="{221A5667-1878-4670-971A-4761DD081DF9}" dt="2026-05-03T02:24:31.144" v="177" actId="478"/>
-          <ac:picMkLst>
-            <pc:docMk/>
-            <pc:sldMk cId="1745904149" sldId="259"/>
-            <ac:picMk id="9" creationId="{786475F2-3940-094E-BF32-869832E57C5C}"/>
-          </ac:picMkLst>
-        </pc:picChg>
-        <pc:picChg chg="add del mod ord">
-          <ac:chgData name="Tolu Atanda" userId="aaf42d42e9a9e251" providerId="LiveId" clId="{221A5667-1878-4670-971A-4761DD081DF9}" dt="2026-05-03T02:25:00.725" v="180" actId="478"/>
-          <ac:picMkLst>
-            <pc:docMk/>
-            <pc:sldMk cId="1745904149" sldId="259"/>
-            <ac:picMk id="13" creationId="{A851C69F-5D46-9CD7-5679-E862101F5D07}"/>
-          </ac:picMkLst>
-        </pc:picChg>
         <pc:picChg chg="add mod">
           <ac:chgData name="Tolu Atanda" userId="aaf42d42e9a9e251" providerId="LiveId" clId="{221A5667-1878-4670-971A-4761DD081DF9}" dt="2026-05-03T02:25:21.576" v="185" actId="26606"/>
           <ac:picMkLst>
@@ -339,14 +264,6 @@
             <pc:docMk/>
             <pc:sldMk cId="2135112449" sldId="260"/>
             <ac:spMk id="2" creationId="{344D0778-AA6D-78AA-038F-F19F4FA50CFF}"/>
-          </ac:spMkLst>
-        </pc:spChg>
-        <pc:spChg chg="del">
-          <ac:chgData name="Tolu Atanda" userId="aaf42d42e9a9e251" providerId="LiveId" clId="{221A5667-1878-4670-971A-4761DD081DF9}" dt="2026-05-03T02:26:49.267" v="190" actId="478"/>
-          <ac:spMkLst>
-            <pc:docMk/>
-            <pc:sldMk cId="2135112449" sldId="260"/>
-            <ac:spMk id="3" creationId="{2522043C-EADA-F5BD-7F04-F039EB9A9C16}"/>
           </ac:spMkLst>
         </pc:spChg>
         <pc:spChg chg="mod">
@@ -396,36 +313,12 @@
             <ac:spMk id="2" creationId="{2537FB83-FBB1-D2EE-D762-256569942BA9}"/>
           </ac:spMkLst>
         </pc:spChg>
-        <pc:spChg chg="del">
-          <ac:chgData name="Tolu Atanda" userId="aaf42d42e9a9e251" providerId="LiveId" clId="{221A5667-1878-4670-971A-4761DD081DF9}" dt="2026-05-03T12:31:19.170" v="237" actId="478"/>
-          <ac:spMkLst>
-            <pc:docMk/>
-            <pc:sldMk cId="1368730174" sldId="261"/>
-            <ac:spMk id="3" creationId="{9D8CD4A3-03A6-1058-C3D6-230F607216D1}"/>
-          </ac:spMkLst>
-        </pc:spChg>
-        <pc:spChg chg="del">
-          <ac:chgData name="Tolu Atanda" userId="aaf42d42e9a9e251" providerId="LiveId" clId="{221A5667-1878-4670-971A-4761DD081DF9}" dt="2026-05-03T12:33:32.007" v="246" actId="26606"/>
-          <ac:spMkLst>
-            <pc:docMk/>
-            <pc:sldMk cId="1368730174" sldId="261"/>
-            <ac:spMk id="4" creationId="{9B118C9E-DCF2-33B2-7864-629D793BA852}"/>
-          </ac:spMkLst>
-        </pc:spChg>
         <pc:spChg chg="add mod">
           <ac:chgData name="Tolu Atanda" userId="aaf42d42e9a9e251" providerId="LiveId" clId="{221A5667-1878-4670-971A-4761DD081DF9}" dt="2026-05-03T13:11:39.875" v="392" actId="2711"/>
           <ac:spMkLst>
             <pc:docMk/>
             <pc:sldMk cId="1368730174" sldId="261"/>
             <ac:spMk id="8" creationId="{26F1BDB9-F9EF-63F5-FF16-0157248B019A}"/>
-          </ac:spMkLst>
-        </pc:spChg>
-        <pc:spChg chg="add del mod">
-          <ac:chgData name="Tolu Atanda" userId="aaf42d42e9a9e251" providerId="LiveId" clId="{221A5667-1878-4670-971A-4761DD081DF9}" dt="2026-05-03T12:37:24.578" v="249" actId="478"/>
-          <ac:spMkLst>
-            <pc:docMk/>
-            <pc:sldMk cId="1368730174" sldId="261"/>
-            <ac:spMk id="10" creationId="{5F5DFEEC-EDBA-DA52-83A1-3D845E1337E5}"/>
           </ac:spMkLst>
         </pc:spChg>
         <pc:spChg chg="add mod">
@@ -436,14 +329,6 @@
             <ac:spMk id="11" creationId="{130E28B7-67B3-05B4-F8EE-81BCF57BBB46}"/>
           </ac:spMkLst>
         </pc:spChg>
-        <pc:graphicFrameChg chg="add mod">
-          <ac:chgData name="Tolu Atanda" userId="aaf42d42e9a9e251" providerId="LiveId" clId="{221A5667-1878-4670-971A-4761DD081DF9}" dt="2026-05-03T13:13:14.764" v="403"/>
-          <ac:graphicFrameMkLst>
-            <pc:docMk/>
-            <pc:sldMk cId="1368730174" sldId="261"/>
-            <ac:graphicFrameMk id="14" creationId="{2A5F91AE-1D4D-3493-0101-E81A7D4C9DB0}"/>
-          </ac:graphicFrameMkLst>
-        </pc:graphicFrameChg>
         <pc:graphicFrameChg chg="add mod modGraphic">
           <ac:chgData name="Tolu Atanda" userId="aaf42d42e9a9e251" providerId="LiveId" clId="{221A5667-1878-4670-971A-4761DD081DF9}" dt="2026-05-03T13:13:43.671" v="410" actId="14100"/>
           <ac:graphicFrameMkLst>
@@ -460,63 +345,15 @@
             <ac:picMk id="5" creationId="{66557C14-8341-1B77-10BC-95BADFACA7C1}"/>
           </ac:picMkLst>
         </pc:picChg>
-        <pc:picChg chg="add del mod">
-          <ac:chgData name="Tolu Atanda" userId="aaf42d42e9a9e251" providerId="LiveId" clId="{221A5667-1878-4670-971A-4761DD081DF9}" dt="2026-05-03T13:12:40.115" v="398" actId="478"/>
-          <ac:picMkLst>
-            <pc:docMk/>
-            <pc:sldMk cId="1368730174" sldId="261"/>
-            <ac:picMk id="6" creationId="{6FB1FDE0-EF73-7FBF-817D-856DC8BF12AA}"/>
-          </ac:picMkLst>
-        </pc:picChg>
-        <pc:picChg chg="add del">
-          <ac:chgData name="Tolu Atanda" userId="aaf42d42e9a9e251" providerId="LiveId" clId="{221A5667-1878-4670-971A-4761DD081DF9}" dt="2026-05-03T13:12:46.201" v="400" actId="478"/>
-          <ac:picMkLst>
-            <pc:docMk/>
-            <pc:sldMk cId="1368730174" sldId="261"/>
-            <ac:picMk id="12" creationId="{D218EF02-8723-D2D8-551E-76221119F218}"/>
-          </ac:picMkLst>
-        </pc:picChg>
-        <pc:picChg chg="add del">
-          <ac:chgData name="Tolu Atanda" userId="aaf42d42e9a9e251" providerId="LiveId" clId="{221A5667-1878-4670-971A-4761DD081DF9}" dt="2026-05-03T13:13:09.302" v="402" actId="478"/>
-          <ac:picMkLst>
-            <pc:docMk/>
-            <pc:sldMk cId="1368730174" sldId="261"/>
-            <ac:picMk id="13" creationId="{050DD613-D1AA-6C2F-0F51-D18EA9EE0D91}"/>
-          </ac:picMkLst>
-        </pc:picChg>
       </pc:sldChg>
       <pc:sldChg chg="addSp delSp modSp new mod chgLayout">
-        <pc:chgData name="Tolu Atanda" userId="aaf42d42e9a9e251" providerId="LiveId" clId="{221A5667-1878-4670-971A-4761DD081DF9}" dt="2026-05-03T13:14:34.971" v="423" actId="14100"/>
+        <pc:chgData name="Tolu Atanda" userId="aaf42d42e9a9e251" providerId="LiveId" clId="{221A5667-1878-4670-971A-4761DD081DF9}" dt="2026-05-05T20:05:10.686" v="483" actId="2711"/>
         <pc:sldMkLst>
           <pc:docMk/>
           <pc:sldMk cId="1797391454" sldId="262"/>
         </pc:sldMkLst>
-        <pc:spChg chg="del">
-          <ac:chgData name="Tolu Atanda" userId="aaf42d42e9a9e251" providerId="LiveId" clId="{221A5667-1878-4670-971A-4761DD081DF9}" dt="2026-05-03T12:39:44.687" v="262" actId="26606"/>
-          <ac:spMkLst>
-            <pc:docMk/>
-            <pc:sldMk cId="1797391454" sldId="262"/>
-            <ac:spMk id="2" creationId="{568AD934-03EF-514F-EE1A-CA619F60B9E1}"/>
-          </ac:spMkLst>
-        </pc:spChg>
-        <pc:spChg chg="del">
-          <ac:chgData name="Tolu Atanda" userId="aaf42d42e9a9e251" providerId="LiveId" clId="{221A5667-1878-4670-971A-4761DD081DF9}" dt="2026-05-03T12:39:05.870" v="260" actId="478"/>
-          <ac:spMkLst>
-            <pc:docMk/>
-            <pc:sldMk cId="1797391454" sldId="262"/>
-            <ac:spMk id="3" creationId="{785D9EBC-97A6-C320-50D4-B9F638BE9ABF}"/>
-          </ac:spMkLst>
-        </pc:spChg>
-        <pc:spChg chg="del">
-          <ac:chgData name="Tolu Atanda" userId="aaf42d42e9a9e251" providerId="LiveId" clId="{221A5667-1878-4670-971A-4761DD081DF9}" dt="2026-05-03T12:39:44.687" v="262" actId="26606"/>
-          <ac:spMkLst>
-            <pc:docMk/>
-            <pc:sldMk cId="1797391454" sldId="262"/>
-            <ac:spMk id="4" creationId="{E11CE286-02F0-2FF2-C60E-50FF98F7E7A2}"/>
-          </ac:spMkLst>
-        </pc:spChg>
         <pc:spChg chg="add mod">
-          <ac:chgData name="Tolu Atanda" userId="aaf42d42e9a9e251" providerId="LiveId" clId="{221A5667-1878-4670-971A-4761DD081DF9}" dt="2026-05-03T13:14:34.971" v="423" actId="14100"/>
+          <ac:chgData name="Tolu Atanda" userId="aaf42d42e9a9e251" providerId="LiveId" clId="{221A5667-1878-4670-971A-4761DD081DF9}" dt="2026-05-05T20:05:10.686" v="483" actId="2711"/>
           <ac:spMkLst>
             <pc:docMk/>
             <pc:sldMk cId="1797391454" sldId="262"/>
@@ -531,28 +368,12 @@
             <ac:spMk id="10" creationId="{4BF1ADCF-DFE8-E377-F18B-F5B3C14FA4DC}"/>
           </ac:spMkLst>
         </pc:spChg>
-        <pc:spChg chg="add del mod">
-          <ac:chgData name="Tolu Atanda" userId="aaf42d42e9a9e251" providerId="LiveId" clId="{221A5667-1878-4670-971A-4761DD081DF9}" dt="2026-05-03T12:40:41.294" v="270" actId="478"/>
-          <ac:spMkLst>
-            <pc:docMk/>
-            <pc:sldMk cId="1797391454" sldId="262"/>
-            <ac:spMk id="12" creationId="{B65C21CC-5B75-E81D-43D9-84609E7F7A5D}"/>
-          </ac:spMkLst>
-        </pc:spChg>
         <pc:picChg chg="add mod">
           <ac:chgData name="Tolu Atanda" userId="aaf42d42e9a9e251" providerId="LiveId" clId="{221A5667-1878-4670-971A-4761DD081DF9}" dt="2026-05-03T13:14:16.514" v="417" actId="14100"/>
           <ac:picMkLst>
             <pc:docMk/>
             <pc:sldMk cId="1797391454" sldId="262"/>
             <ac:picMk id="5" creationId="{62C52422-4119-7943-EFD5-E13AAECB80F6}"/>
-          </ac:picMkLst>
-        </pc:picChg>
-        <pc:picChg chg="add del mod">
-          <ac:chgData name="Tolu Atanda" userId="aaf42d42e9a9e251" providerId="LiveId" clId="{221A5667-1878-4670-971A-4761DD081DF9}" dt="2026-05-03T12:43:20.519" v="275" actId="478"/>
-          <ac:picMkLst>
-            <pc:docMk/>
-            <pc:sldMk cId="1797391454" sldId="262"/>
-            <ac:picMk id="8" creationId="{421DF535-1EAB-A151-05D4-82BECBBCC60B}"/>
           </ac:picMkLst>
         </pc:picChg>
         <pc:picChg chg="add mod">
@@ -578,22 +399,6 @@
             <ac:spMk id="2" creationId="{230A3814-A6F7-B1FA-164C-767A3828E455}"/>
           </ac:spMkLst>
         </pc:spChg>
-        <pc:spChg chg="del">
-          <ac:chgData name="Tolu Atanda" userId="aaf42d42e9a9e251" providerId="LiveId" clId="{221A5667-1878-4670-971A-4761DD081DF9}" dt="2026-05-03T12:45:00.702" v="277" actId="478"/>
-          <ac:spMkLst>
-            <pc:docMk/>
-            <pc:sldMk cId="3142278650" sldId="263"/>
-            <ac:spMk id="3" creationId="{BCF92E78-19B9-F1B8-B924-92B96EF1DD51}"/>
-          </ac:spMkLst>
-        </pc:spChg>
-        <pc:spChg chg="del">
-          <ac:chgData name="Tolu Atanda" userId="aaf42d42e9a9e251" providerId="LiveId" clId="{221A5667-1878-4670-971A-4761DD081DF9}" dt="2026-05-03T12:45:03.782" v="278" actId="478"/>
-          <ac:spMkLst>
-            <pc:docMk/>
-            <pc:sldMk cId="3142278650" sldId="263"/>
-            <ac:spMk id="4" creationId="{9ED6029D-ACDE-E0C9-491A-B94E1D630DE9}"/>
-          </ac:spMkLst>
-        </pc:spChg>
         <pc:spChg chg="add mod ord">
           <ac:chgData name="Tolu Atanda" userId="aaf42d42e9a9e251" providerId="LiveId" clId="{221A5667-1878-4670-971A-4761DD081DF9}" dt="2026-05-03T13:15:25.825" v="429" actId="27636"/>
           <ac:spMkLst>
@@ -610,36 +415,12 @@
             <ac:graphicFrameMk id="11" creationId="{B987E24A-CF39-BB6A-0C41-DE1DA7FE41EB}"/>
           </ac:graphicFrameMkLst>
         </pc:graphicFrameChg>
-        <pc:picChg chg="add del mod">
-          <ac:chgData name="Tolu Atanda" userId="aaf42d42e9a9e251" providerId="LiveId" clId="{221A5667-1878-4670-971A-4761DD081DF9}" dt="2026-05-03T12:52:40.011" v="296" actId="478"/>
-          <ac:picMkLst>
-            <pc:docMk/>
-            <pc:sldMk cId="3142278650" sldId="263"/>
-            <ac:picMk id="5" creationId="{3CCE8C1B-BDE4-DF0C-9103-D094E990D480}"/>
-          </ac:picMkLst>
-        </pc:picChg>
         <pc:picChg chg="add mod">
           <ac:chgData name="Tolu Atanda" userId="aaf42d42e9a9e251" providerId="LiveId" clId="{221A5667-1878-4670-971A-4761DD081DF9}" dt="2026-05-03T12:52:47.401" v="297" actId="26606"/>
           <ac:picMkLst>
             <pc:docMk/>
             <pc:sldMk cId="3142278650" sldId="263"/>
             <ac:picMk id="8" creationId="{B5D9EB81-9D42-3213-C3E7-5BFC474A91DC}"/>
-          </ac:picMkLst>
-        </pc:picChg>
-        <pc:picChg chg="add del mod">
-          <ac:chgData name="Tolu Atanda" userId="aaf42d42e9a9e251" providerId="LiveId" clId="{221A5667-1878-4670-971A-4761DD081DF9}" dt="2026-05-03T13:15:16.073" v="427" actId="478"/>
-          <ac:picMkLst>
-            <pc:docMk/>
-            <pc:sldMk cId="3142278650" sldId="263"/>
-            <ac:picMk id="9" creationId="{94210B2F-4F78-8863-99C2-F1FE10010DE7}"/>
-          </ac:picMkLst>
-        </pc:picChg>
-        <pc:picChg chg="add del">
-          <ac:chgData name="Tolu Atanda" userId="aaf42d42e9a9e251" providerId="LiveId" clId="{221A5667-1878-4670-971A-4761DD081DF9}" dt="2026-05-03T13:15:32.189" v="431" actId="478"/>
-          <ac:picMkLst>
-            <pc:docMk/>
-            <pc:sldMk cId="3142278650" sldId="263"/>
-            <ac:picMk id="10" creationId="{4210005E-6BD9-F344-06E2-2EDF4D646AD0}"/>
           </ac:picMkLst>
         </pc:picChg>
       </pc:sldChg>
@@ -655,22 +436,6 @@
             <pc:docMk/>
             <pc:sldMk cId="1331583684" sldId="264"/>
             <ac:spMk id="2" creationId="{C317BC00-C90B-D6EA-29A3-C50BD3B97B68}"/>
-          </ac:spMkLst>
-        </pc:spChg>
-        <pc:spChg chg="del">
-          <ac:chgData name="Tolu Atanda" userId="aaf42d42e9a9e251" providerId="LiveId" clId="{221A5667-1878-4670-971A-4761DD081DF9}" dt="2026-05-03T12:49:16.870" v="291" actId="478"/>
-          <ac:spMkLst>
-            <pc:docMk/>
-            <pc:sldMk cId="1331583684" sldId="264"/>
-            <ac:spMk id="3" creationId="{FB70D5FA-95FD-D314-4829-D376AFAC6BD5}"/>
-          </ac:spMkLst>
-        </pc:spChg>
-        <pc:spChg chg="del">
-          <ac:chgData name="Tolu Atanda" userId="aaf42d42e9a9e251" providerId="LiveId" clId="{221A5667-1878-4670-971A-4761DD081DF9}" dt="2026-05-03T12:49:20.017" v="292" actId="478"/>
-          <ac:spMkLst>
-            <pc:docMk/>
-            <pc:sldMk cId="1331583684" sldId="264"/>
-            <ac:spMk id="4" creationId="{5FE830B8-1AB2-E3FB-8C78-A0DB9C9E2454}"/>
           </ac:spMkLst>
         </pc:spChg>
         <pc:spChg chg="add mod">
@@ -697,14 +462,6 @@
             <ac:picMk id="5" creationId="{D7BD7822-EC35-08DD-5988-02E37769C113}"/>
           </ac:picMkLst>
         </pc:picChg>
-        <pc:picChg chg="add del mod">
-          <ac:chgData name="Tolu Atanda" userId="aaf42d42e9a9e251" providerId="LiveId" clId="{221A5667-1878-4670-971A-4761DD081DF9}" dt="2026-05-03T13:15:58.460" v="436" actId="478"/>
-          <ac:picMkLst>
-            <pc:docMk/>
-            <pc:sldMk cId="1331583684" sldId="264"/>
-            <ac:picMk id="6" creationId="{B430337E-56CA-12E0-DC64-316E25B15611}"/>
-          </ac:picMkLst>
-        </pc:picChg>
       </pc:sldChg>
       <pc:sldChg chg="delSp modSp new mod chgLayout">
         <pc:chgData name="Tolu Atanda" userId="aaf42d42e9a9e251" providerId="LiveId" clId="{221A5667-1878-4670-971A-4761DD081DF9}" dt="2026-05-03T12:56:33.768" v="324" actId="26606"/>
@@ -718,14 +475,6 @@
             <pc:docMk/>
             <pc:sldMk cId="2804337408" sldId="265"/>
             <ac:spMk id="2" creationId="{CE12A1CE-EC19-68FC-30A4-41D399A9F235}"/>
-          </ac:spMkLst>
-        </pc:spChg>
-        <pc:spChg chg="del">
-          <ac:chgData name="Tolu Atanda" userId="aaf42d42e9a9e251" providerId="LiveId" clId="{221A5667-1878-4670-971A-4761DD081DF9}" dt="2026-05-03T12:55:19.793" v="319" actId="478"/>
-          <ac:spMkLst>
-            <pc:docMk/>
-            <pc:sldMk cId="2804337408" sldId="265"/>
-            <ac:spMk id="3" creationId="{7B4C9222-4109-29A8-0914-BD3D90F32204}"/>
           </ac:spMkLst>
         </pc:spChg>
         <pc:spChg chg="mod">
@@ -749,14 +498,6 @@
             <pc:docMk/>
             <pc:sldMk cId="593938385" sldId="266"/>
             <ac:spMk id="2" creationId="{26A213D0-888C-7B01-49C8-1918343A2725}"/>
-          </ac:spMkLst>
-        </pc:spChg>
-        <pc:spChg chg="del">
-          <ac:chgData name="Tolu Atanda" userId="aaf42d42e9a9e251" providerId="LiveId" clId="{221A5667-1878-4670-971A-4761DD081DF9}" dt="2026-05-03T12:56:57.466" v="326" actId="478"/>
-          <ac:spMkLst>
-            <pc:docMk/>
-            <pc:sldMk cId="593938385" sldId="266"/>
-            <ac:spMk id="3" creationId="{E09A3B40-B915-47CE-7C26-75FE1DFE6BB9}"/>
           </ac:spMkLst>
         </pc:spChg>
         <pc:spChg chg="mod">
@@ -790,14 +531,6 @@
             <ac:spMk id="2" creationId="{9FBB12B7-018B-130E-D244-5A6F9319EB74}"/>
           </ac:spMkLst>
         </pc:spChg>
-        <pc:spChg chg="del">
-          <ac:chgData name="Tolu Atanda" userId="aaf42d42e9a9e251" providerId="LiveId" clId="{221A5667-1878-4670-971A-4761DD081DF9}" dt="2026-05-03T13:00:22.206" v="337" actId="478"/>
-          <ac:spMkLst>
-            <pc:docMk/>
-            <pc:sldMk cId="2792343568" sldId="267"/>
-            <ac:spMk id="3" creationId="{56E0FA4B-C6AC-A1F0-6476-8B9810602459}"/>
-          </ac:spMkLst>
-        </pc:spChg>
         <pc:spChg chg="mod">
           <ac:chgData name="Tolu Atanda" userId="aaf42d42e9a9e251" providerId="LiveId" clId="{221A5667-1878-4670-971A-4761DD081DF9}" dt="2026-05-03T13:19:23.468" v="450" actId="5793"/>
           <ac:spMkLst>
@@ -827,14 +560,6 @@
             <pc:docMk/>
             <pc:sldMk cId="4263276072" sldId="268"/>
             <ac:spMk id="2" creationId="{52A050A0-00FB-EB5A-4948-CED3A377DE26}"/>
-          </ac:spMkLst>
-        </pc:spChg>
-        <pc:spChg chg="del">
-          <ac:chgData name="Tolu Atanda" userId="aaf42d42e9a9e251" providerId="LiveId" clId="{221A5667-1878-4670-971A-4761DD081DF9}" dt="2026-05-03T13:01:02.757" v="341" actId="478"/>
-          <ac:spMkLst>
-            <pc:docMk/>
-            <pc:sldMk cId="4263276072" sldId="268"/>
-            <ac:spMk id="3" creationId="{3AE50847-45D6-624E-395B-406E91C53E26}"/>
           </ac:spMkLst>
         </pc:spChg>
         <pc:spChg chg="mod">
@@ -876,14 +601,6 @@
             <ac:spMk id="2" creationId="{6E727806-D665-DD75-3467-132752AD984B}"/>
           </ac:spMkLst>
         </pc:spChg>
-        <pc:spChg chg="del">
-          <ac:chgData name="Tolu Atanda" userId="aaf42d42e9a9e251" providerId="LiveId" clId="{221A5667-1878-4670-971A-4761DD081DF9}" dt="2026-05-03T13:04:03.754" v="352" actId="478"/>
-          <ac:spMkLst>
-            <pc:docMk/>
-            <pc:sldMk cId="3924200248" sldId="269"/>
-            <ac:spMk id="3" creationId="{8AEF2FEF-F644-8B65-264A-C603E6C5B329}"/>
-          </ac:spMkLst>
-        </pc:spChg>
         <pc:spChg chg="mod">
           <ac:chgData name="Tolu Atanda" userId="aaf42d42e9a9e251" providerId="LiveId" clId="{221A5667-1878-4670-971A-4761DD081DF9}" dt="2026-05-03T13:23:53.339" v="480" actId="2711"/>
           <ac:spMkLst>
@@ -923,14 +640,6 @@
             <ac:spMk id="2" creationId="{206488AB-0082-ED73-B262-997742A2F257}"/>
           </ac:spMkLst>
         </pc:spChg>
-        <pc:spChg chg="del">
-          <ac:chgData name="Tolu Atanda" userId="aaf42d42e9a9e251" providerId="LiveId" clId="{221A5667-1878-4670-971A-4761DD081DF9}" dt="2026-05-03T13:06:47.264" v="368" actId="478"/>
-          <ac:spMkLst>
-            <pc:docMk/>
-            <pc:sldMk cId="1408905252" sldId="270"/>
-            <ac:spMk id="3" creationId="{BDA7F6F5-783A-6FBF-1139-505EDAF07A9F}"/>
-          </ac:spMkLst>
-        </pc:spChg>
         <pc:spChg chg="mod">
           <ac:chgData name="Tolu Atanda" userId="aaf42d42e9a9e251" providerId="LiveId" clId="{221A5667-1878-4670-971A-4761DD081DF9}" dt="2026-05-03T13:24:11.286" v="481" actId="26606"/>
           <ac:spMkLst>
@@ -954,22 +663,6 @@
             <ac:spMk id="2" creationId="{523ECDC9-7C1B-DC0E-7DBD-CEF8AC28F4EB}"/>
           </ac:spMkLst>
         </pc:spChg>
-        <pc:spChg chg="del">
-          <ac:chgData name="Tolu Atanda" userId="aaf42d42e9a9e251" providerId="LiveId" clId="{221A5667-1878-4670-971A-4761DD081DF9}" dt="2026-05-03T13:09:17.467" v="381" actId="478"/>
-          <ac:spMkLst>
-            <pc:docMk/>
-            <pc:sldMk cId="1875772830" sldId="271"/>
-            <ac:spMk id="3" creationId="{81884837-92D0-7945-891B-4451A907773E}"/>
-          </ac:spMkLst>
-        </pc:spChg>
-        <pc:spChg chg="del mod">
-          <ac:chgData name="Tolu Atanda" userId="aaf42d42e9a9e251" providerId="LiveId" clId="{221A5667-1878-4670-971A-4761DD081DF9}" dt="2026-05-03T13:24:47.284" v="482" actId="26606"/>
-          <ac:spMkLst>
-            <pc:docMk/>
-            <pc:sldMk cId="1875772830" sldId="271"/>
-            <ac:spMk id="4" creationId="{D7B0BD74-E4A0-E92A-64B8-B54831476635}"/>
-          </ac:spMkLst>
-        </pc:spChg>
         <pc:graphicFrameChg chg="add mod">
           <ac:chgData name="Tolu Atanda" userId="aaf42d42e9a9e251" providerId="LiveId" clId="{221A5667-1878-4670-971A-4761DD081DF9}" dt="2026-05-03T13:24:47.284" v="482" actId="26606"/>
           <ac:graphicFrameMkLst>
@@ -979,101 +672,6 @@
           </ac:graphicFrameMkLst>
         </pc:graphicFrameChg>
       </pc:sldChg>
-      <pc:sldMasterChg chg="del delSldLayout">
-        <pc:chgData name="Tolu Atanda" userId="aaf42d42e9a9e251" providerId="LiveId" clId="{221A5667-1878-4670-971A-4761DD081DF9}" dt="2026-05-03T02:09:50.393" v="114" actId="26606"/>
-        <pc:sldMasterMkLst>
-          <pc:docMk/>
-          <pc:sldMasterMk cId="1527765347" sldId="2147483648"/>
-        </pc:sldMasterMkLst>
-        <pc:sldLayoutChg chg="del">
-          <pc:chgData name="Tolu Atanda" userId="aaf42d42e9a9e251" providerId="LiveId" clId="{221A5667-1878-4670-971A-4761DD081DF9}" dt="2026-05-03T02:09:50.393" v="114" actId="26606"/>
-          <pc:sldLayoutMkLst>
-            <pc:docMk/>
-            <pc:sldMasterMk cId="1527765347" sldId="2147483648"/>
-            <pc:sldLayoutMk cId="2120846246" sldId="2147483649"/>
-          </pc:sldLayoutMkLst>
-        </pc:sldLayoutChg>
-        <pc:sldLayoutChg chg="del">
-          <pc:chgData name="Tolu Atanda" userId="aaf42d42e9a9e251" providerId="LiveId" clId="{221A5667-1878-4670-971A-4761DD081DF9}" dt="2026-05-03T02:09:50.393" v="114" actId="26606"/>
-          <pc:sldLayoutMkLst>
-            <pc:docMk/>
-            <pc:sldMasterMk cId="1527765347" sldId="2147483648"/>
-            <pc:sldLayoutMk cId="3512033021" sldId="2147483650"/>
-          </pc:sldLayoutMkLst>
-        </pc:sldLayoutChg>
-        <pc:sldLayoutChg chg="del">
-          <pc:chgData name="Tolu Atanda" userId="aaf42d42e9a9e251" providerId="LiveId" clId="{221A5667-1878-4670-971A-4761DD081DF9}" dt="2026-05-03T02:09:50.393" v="114" actId="26606"/>
-          <pc:sldLayoutMkLst>
-            <pc:docMk/>
-            <pc:sldMasterMk cId="1527765347" sldId="2147483648"/>
-            <pc:sldLayoutMk cId="478491816" sldId="2147483651"/>
-          </pc:sldLayoutMkLst>
-        </pc:sldLayoutChg>
-        <pc:sldLayoutChg chg="del">
-          <pc:chgData name="Tolu Atanda" userId="aaf42d42e9a9e251" providerId="LiveId" clId="{221A5667-1878-4670-971A-4761DD081DF9}" dt="2026-05-03T02:09:50.393" v="114" actId="26606"/>
-          <pc:sldLayoutMkLst>
-            <pc:docMk/>
-            <pc:sldMasterMk cId="1527765347" sldId="2147483648"/>
-            <pc:sldLayoutMk cId="286608542" sldId="2147483652"/>
-          </pc:sldLayoutMkLst>
-        </pc:sldLayoutChg>
-        <pc:sldLayoutChg chg="del">
-          <pc:chgData name="Tolu Atanda" userId="aaf42d42e9a9e251" providerId="LiveId" clId="{221A5667-1878-4670-971A-4761DD081DF9}" dt="2026-05-03T02:09:50.393" v="114" actId="26606"/>
-          <pc:sldLayoutMkLst>
-            <pc:docMk/>
-            <pc:sldMasterMk cId="1527765347" sldId="2147483648"/>
-            <pc:sldLayoutMk cId="1220407676" sldId="2147483653"/>
-          </pc:sldLayoutMkLst>
-        </pc:sldLayoutChg>
-        <pc:sldLayoutChg chg="del">
-          <pc:chgData name="Tolu Atanda" userId="aaf42d42e9a9e251" providerId="LiveId" clId="{221A5667-1878-4670-971A-4761DD081DF9}" dt="2026-05-03T02:09:50.393" v="114" actId="26606"/>
-          <pc:sldLayoutMkLst>
-            <pc:docMk/>
-            <pc:sldMasterMk cId="1527765347" sldId="2147483648"/>
-            <pc:sldLayoutMk cId="4249123085" sldId="2147483654"/>
-          </pc:sldLayoutMkLst>
-        </pc:sldLayoutChg>
-        <pc:sldLayoutChg chg="del">
-          <pc:chgData name="Tolu Atanda" userId="aaf42d42e9a9e251" providerId="LiveId" clId="{221A5667-1878-4670-971A-4761DD081DF9}" dt="2026-05-03T02:09:50.393" v="114" actId="26606"/>
-          <pc:sldLayoutMkLst>
-            <pc:docMk/>
-            <pc:sldMasterMk cId="1527765347" sldId="2147483648"/>
-            <pc:sldLayoutMk cId="184792420" sldId="2147483655"/>
-          </pc:sldLayoutMkLst>
-        </pc:sldLayoutChg>
-        <pc:sldLayoutChg chg="del">
-          <pc:chgData name="Tolu Atanda" userId="aaf42d42e9a9e251" providerId="LiveId" clId="{221A5667-1878-4670-971A-4761DD081DF9}" dt="2026-05-03T02:09:50.393" v="114" actId="26606"/>
-          <pc:sldLayoutMkLst>
-            <pc:docMk/>
-            <pc:sldMasterMk cId="1527765347" sldId="2147483648"/>
-            <pc:sldLayoutMk cId="1633796923" sldId="2147483656"/>
-          </pc:sldLayoutMkLst>
-        </pc:sldLayoutChg>
-        <pc:sldLayoutChg chg="del">
-          <pc:chgData name="Tolu Atanda" userId="aaf42d42e9a9e251" providerId="LiveId" clId="{221A5667-1878-4670-971A-4761DD081DF9}" dt="2026-05-03T02:09:50.393" v="114" actId="26606"/>
-          <pc:sldLayoutMkLst>
-            <pc:docMk/>
-            <pc:sldMasterMk cId="1527765347" sldId="2147483648"/>
-            <pc:sldLayoutMk cId="2621649489" sldId="2147483657"/>
-          </pc:sldLayoutMkLst>
-        </pc:sldLayoutChg>
-        <pc:sldLayoutChg chg="del">
-          <pc:chgData name="Tolu Atanda" userId="aaf42d42e9a9e251" providerId="LiveId" clId="{221A5667-1878-4670-971A-4761DD081DF9}" dt="2026-05-03T02:09:50.393" v="114" actId="26606"/>
-          <pc:sldLayoutMkLst>
-            <pc:docMk/>
-            <pc:sldMasterMk cId="1527765347" sldId="2147483648"/>
-            <pc:sldLayoutMk cId="711960464" sldId="2147483658"/>
-          </pc:sldLayoutMkLst>
-        </pc:sldLayoutChg>
-        <pc:sldLayoutChg chg="del">
-          <pc:chgData name="Tolu Atanda" userId="aaf42d42e9a9e251" providerId="LiveId" clId="{221A5667-1878-4670-971A-4761DD081DF9}" dt="2026-05-03T02:09:50.393" v="114" actId="26606"/>
-          <pc:sldLayoutMkLst>
-            <pc:docMk/>
-            <pc:sldMasterMk cId="1527765347" sldId="2147483648"/>
-            <pc:sldLayoutMk cId="428710214" sldId="2147483659"/>
-          </pc:sldLayoutMkLst>
-        </pc:sldLayoutChg>
-      </pc:sldMasterChg>
       <pc:sldMasterChg chg="add addSldLayout">
         <pc:chgData name="Tolu Atanda" userId="aaf42d42e9a9e251" providerId="LiveId" clId="{221A5667-1878-4670-971A-4761DD081DF9}" dt="2026-05-03T02:09:50.393" v="114" actId="26606"/>
         <pc:sldMasterMkLst>
@@ -3163,7 +2761,7 @@
         <a:lstStyle/>
         <a:p>
           <a:r>
-            <a:rPr lang="en-US"/>
+            <a:rPr lang="en-US" dirty="0"/>
             <a:t>Claim occurrence</a:t>
           </a:r>
         </a:p>
@@ -4492,7 +4090,7 @@
             <a:buNone/>
           </a:pPr>
           <a:r>
-            <a:rPr lang="en-US" sz="2600" kern="1200"/>
+            <a:rPr lang="en-US" sz="2600" kern="1200" dirty="0"/>
             <a:t>Claim occurrence</a:t>
           </a:r>
         </a:p>
@@ -8725,7 +8323,7 @@
           <a:p>
             <a:fld id="{D29CF56E-D922-4450-9794-8B0E1451F6EB}" type="datetime1">
               <a:rPr lang="en-US" smtClean="0"/>
-              <a:t>5/2/2026</a:t>
+              <a:t>5/5/2026</a:t>
             </a:fld>
             <a:endParaRPr lang="en-US" dirty="0"/>
           </a:p>
@@ -9302,7 +8900,7 @@
           <a:p>
             <a:fld id="{9C5C1F80-0989-4135-BEC0-53996BCA1D73}" type="datetime1">
               <a:rPr lang="en-US" smtClean="0"/>
-              <a:t>5/2/2026</a:t>
+              <a:t>5/5/2026</a:t>
             </a:fld>
             <a:endParaRPr lang="en-US" dirty="0"/>
           </a:p>
@@ -9860,7 +9458,7 @@
           <a:p>
             <a:fld id="{2B346B3B-D23C-46FC-82B4-EC936862EBB6}" type="datetime1">
               <a:rPr lang="en-US" smtClean="0"/>
-              <a:t>5/2/2026</a:t>
+              <a:t>5/5/2026</a:t>
             </a:fld>
             <a:endParaRPr lang="en-US" dirty="0"/>
           </a:p>
@@ -10390,7 +9988,7 @@
           <a:p>
             <a:fld id="{11039C6F-01AE-405F-93D2-431591D79461}" type="datetime1">
               <a:rPr lang="en-US" smtClean="0"/>
-              <a:t>5/2/2026</a:t>
+              <a:t>5/5/2026</a:t>
             </a:fld>
             <a:endParaRPr lang="en-US" dirty="0"/>
           </a:p>
@@ -10793,7 +10391,7 @@
           <a:p>
             <a:fld id="{6AE82713-2685-4CB9-BD26-DD329F3C67A6}" type="datetime1">
               <a:rPr lang="en-US" smtClean="0"/>
-              <a:t>5/2/2026</a:t>
+              <a:t>5/5/2026</a:t>
             </a:fld>
             <a:endParaRPr lang="en-US" dirty="0"/>
           </a:p>
@@ -11192,7 +10790,7 @@
           <a:p>
             <a:fld id="{957926B3-CA5D-44FB-BC2D-6B05FBB97B04}" type="datetime1">
               <a:rPr lang="en-US" smtClean="0"/>
-              <a:t>5/2/2026</a:t>
+              <a:t>5/5/2026</a:t>
             </a:fld>
             <a:endParaRPr lang="en-US" dirty="0"/>
           </a:p>
@@ -11590,7 +11188,7 @@
           <a:p>
             <a:fld id="{7E009212-C305-41EC-8687-C39B36C09AF0}" type="datetime1">
               <a:rPr lang="en-US" smtClean="0"/>
-              <a:t>5/2/2026</a:t>
+              <a:t>5/5/2026</a:t>
             </a:fld>
             <a:endParaRPr lang="en-US" dirty="0"/>
           </a:p>
@@ -11989,7 +11587,7 @@
           <a:p>
             <a:fld id="{7CD886C8-FB0E-44DB-9413-26C9933623BA}" type="datetime1">
               <a:rPr lang="en-US" smtClean="0"/>
-              <a:t>5/2/2026</a:t>
+              <a:t>5/5/2026</a:t>
             </a:fld>
             <a:endParaRPr lang="en-US" dirty="0"/>
           </a:p>
@@ -12389,7 +11987,7 @@
           <a:p>
             <a:fld id="{278A6864-E7E2-494F-A90A-ECC53613C6EC}" type="datetime1">
               <a:rPr lang="en-US" smtClean="0"/>
-              <a:t>5/2/2026</a:t>
+              <a:t>5/5/2026</a:t>
             </a:fld>
             <a:endParaRPr lang="en-US" dirty="0"/>
           </a:p>
@@ -12756,7 +12354,7 @@
           <a:p>
             <a:fld id="{2F4ED686-7864-484B-8047-F06E855FD995}" type="datetime1">
               <a:rPr lang="en-US" smtClean="0"/>
-              <a:t>5/2/2026</a:t>
+              <a:t>5/5/2026</a:t>
             </a:fld>
             <a:endParaRPr lang="en-US" dirty="0"/>
           </a:p>
@@ -13137,7 +12735,7 @@
           <a:p>
             <a:fld id="{CB8F8C76-8E31-4D47-BC79-85F35E81929B}" type="datetime1">
               <a:rPr lang="en-US" smtClean="0"/>
-              <a:t>5/2/2026</a:t>
+              <a:t>5/5/2026</a:t>
             </a:fld>
             <a:endParaRPr lang="en-US" dirty="0"/>
           </a:p>
@@ -13516,7 +13114,7 @@
           <a:p>
             <a:fld id="{CBE1C96F-46D7-47BB-8945-9667BCB4F5BB}" type="datetime1">
               <a:rPr lang="en-US" smtClean="0"/>
-              <a:t>5/2/2026</a:t>
+              <a:t>5/5/2026</a:t>
             </a:fld>
             <a:endParaRPr lang="en-US" dirty="0"/>
           </a:p>
@@ -13949,7 +13547,7 @@
           <a:p>
             <a:fld id="{85640267-1344-46BE-B105-162E68855468}" type="datetime1">
               <a:rPr lang="en-US" smtClean="0"/>
-              <a:t>5/2/2026</a:t>
+              <a:t>5/5/2026</a:t>
             </a:fld>
             <a:endParaRPr lang="en-US" dirty="0"/>
           </a:p>
@@ -14366,7 +13964,7 @@
           <a:p>
             <a:fld id="{1C45E567-307A-4358-87B7-AFD16C4C07D5}" type="datetime1">
               <a:rPr lang="en-US" smtClean="0"/>
-              <a:t>5/2/2026</a:t>
+              <a:t>5/5/2026</a:t>
             </a:fld>
             <a:endParaRPr lang="en-US" dirty="0"/>
           </a:p>
@@ -14584,7 +14182,7 @@
           <a:p>
             <a:fld id="{E016730A-3443-4D7F-BC47-3A3CDB3837FC}" type="datetime1">
               <a:rPr lang="en-US" smtClean="0"/>
-              <a:t>5/2/2026</a:t>
+              <a:t>5/5/2026</a:t>
             </a:fld>
             <a:endParaRPr lang="en-US" dirty="0"/>
           </a:p>
@@ -15201,7 +14799,7 @@
           <a:p>
             <a:fld id="{D9193AC5-F257-4C01-8A7B-A4CD87F22F04}" type="datetime1">
               <a:rPr lang="en-US" smtClean="0"/>
-              <a:t>5/2/2026</a:t>
+              <a:t>5/5/2026</a:t>
             </a:fld>
             <a:endParaRPr lang="en-US" dirty="0"/>
           </a:p>
@@ -15572,7 +15170,7 @@
           <a:p>
             <a:fld id="{A64EBB10-E93E-4729-97C4-FAB8DF4548E2}" type="datetime1">
               <a:rPr lang="en-US" smtClean="0"/>
-              <a:t>5/2/2026</a:t>
+              <a:t>5/5/2026</a:t>
             </a:fld>
             <a:endParaRPr lang="en-US" dirty="0"/>
           </a:p>
@@ -15845,7 +15443,7 @@
           <a:p>
             <a:fld id="{7040DD2C-7FC6-41A9-87A2-29E4EDD4A815}" type="datetime1">
               <a:rPr lang="en-US" smtClean="0"/>
-              <a:t>5/2/2026</a:t>
+              <a:t>5/5/2026</a:t>
             </a:fld>
             <a:endParaRPr lang="en-US" dirty="0"/>
           </a:p>
@@ -16470,7 +16068,7 @@
           <a:p>
             <a:fld id="{C8E3A8ED-7C53-48B7-8E07-F767A8357B67}" type="datetime1">
               <a:rPr lang="en-US" smtClean="0"/>
-              <a:t>5/2/2026</a:t>
+              <a:t>5/5/2026</a:t>
             </a:fld>
             <a:endParaRPr lang="en-US" dirty="0"/>
           </a:p>
@@ -16905,7 +16503,7 @@
           <a:p>
             <a:fld id="{81AC3B39-0D1D-4C0E-BE8E-C570B18D6B3B}" type="datetime1">
               <a:rPr lang="en-US" smtClean="0"/>
-              <a:t>5/2/2026</a:t>
+              <a:t>5/5/2026</a:t>
             </a:fld>
             <a:endParaRPr lang="en-US" dirty="0"/>
           </a:p>
@@ -17154,7 +16752,7 @@
           <a:p>
             <a:fld id="{0780F3AB-C899-4854-A4A4-B2E20F203358}" type="datetime1">
               <a:rPr lang="en-US" smtClean="0"/>
-              <a:t>5/2/2026</a:t>
+              <a:t>5/5/2026</a:t>
             </a:fld>
             <a:endParaRPr lang="en-US" dirty="0"/>
           </a:p>
@@ -17794,7 +17392,7 @@
           <a:p>
             <a:fld id="{1095A040-388D-41D5-A09F-3EC1A1D097A8}" type="datetime1">
               <a:rPr lang="en-US" smtClean="0"/>
-              <a:t>5/2/2026</a:t>
+              <a:t>5/5/2026</a:t>
             </a:fld>
             <a:endParaRPr lang="en-US" dirty="0"/>
           </a:p>
@@ -18214,7 +17812,7 @@
           <a:p>
             <a:fld id="{A6379DD5-AE65-4D02-9BCE-257CC17A63B7}" type="datetime1">
               <a:rPr lang="en-US" smtClean="0"/>
-              <a:t>5/2/2026</a:t>
+              <a:t>5/5/2026</a:t>
             </a:fld>
             <a:endParaRPr lang="en-US" dirty="0"/>
           </a:p>
@@ -18656,7 +18254,7 @@
           <a:p>
             <a:fld id="{5ECB542C-378A-4AAF-83EE-A3767FF83605}" type="datetime1">
               <a:rPr lang="en-US" smtClean="0"/>
-              <a:t>5/2/2026</a:t>
+              <a:t>5/5/2026</a:t>
             </a:fld>
             <a:endParaRPr lang="en-US"/>
           </a:p>
@@ -18948,7 +18546,7 @@
           <a:p>
             <a:fld id="{16C6F251-EB74-4ADA-AD63-D85EC3A9D616}" type="datetime1">
               <a:rPr lang="en-US" smtClean="0"/>
-              <a:t>5/2/2026</a:t>
+              <a:t>5/5/2026</a:t>
             </a:fld>
             <a:endParaRPr lang="en-US" dirty="0"/>
           </a:p>
@@ -19356,7 +18954,7 @@
           <a:p>
             <a:fld id="{7305F46D-792E-48B7-9047-8A1672515077}" type="datetime1">
               <a:rPr lang="en-US" smtClean="0"/>
-              <a:t>5/2/2026</a:t>
+              <a:t>5/5/2026</a:t>
             </a:fld>
             <a:endParaRPr lang="en-US" dirty="0"/>
           </a:p>
@@ -19764,7 +19362,7 @@
           <a:p>
             <a:fld id="{8B53D3FE-D727-4B50-874D-41D5E635B20A}" type="datetime1">
               <a:rPr lang="en-US" smtClean="0"/>
-              <a:t>5/2/2026</a:t>
+              <a:t>5/5/2026</a:t>
             </a:fld>
             <a:endParaRPr lang="en-US" dirty="0"/>
           </a:p>
@@ -20172,7 +19770,7 @@
           <a:p>
             <a:fld id="{FE942071-3A2D-4B86-82F9-428DB212BAF8}" type="datetime1">
               <a:rPr lang="en-US" smtClean="0"/>
-              <a:t>5/2/2026</a:t>
+              <a:t>5/5/2026</a:t>
             </a:fld>
             <a:endParaRPr lang="en-US" dirty="0"/>
           </a:p>
@@ -20853,7 +20451,7 @@
           <a:p>
             <a:fld id="{040D1012-6B36-4753-8153-E5F982239567}" type="datetime1">
               <a:rPr lang="en-US" smtClean="0"/>
-              <a:t>5/2/2026</a:t>
+              <a:t>5/5/2026</a:t>
             </a:fld>
             <a:endParaRPr lang="en-US" dirty="0"/>
           </a:p>
@@ -21046,7 +20644,7 @@
           <a:p>
             <a:fld id="{02E2BBBB-FE25-456C-89E4-A0303F0273E5}" type="datetime1">
               <a:rPr lang="en-US" smtClean="0"/>
-              <a:t>5/2/2026</a:t>
+              <a:t>5/5/2026</a:t>
             </a:fld>
             <a:endParaRPr lang="en-US" dirty="0"/>
           </a:p>
@@ -21263,7 +20861,7 @@
           <a:p>
             <a:fld id="{1315EE4B-219D-4799-AB8D-57B100451C5D}" type="datetime1">
               <a:rPr lang="en-US" smtClean="0"/>
-              <a:t>5/2/2026</a:t>
+              <a:t>5/5/2026</a:t>
             </a:fld>
             <a:endParaRPr lang="en-US" dirty="0"/>
           </a:p>
@@ -21603,7 +21201,7 @@
           <a:p>
             <a:fld id="{6499AFF4-C109-45E7-87CB-3A41EC6C3342}" type="datetime1">
               <a:rPr lang="en-US" smtClean="0"/>
-              <a:t>5/2/2026</a:t>
+              <a:t>5/5/2026</a:t>
             </a:fld>
             <a:endParaRPr lang="en-US" dirty="0"/>
           </a:p>
@@ -22618,7 +22216,7 @@
           <a:p>
             <a:fld id="{50AFEFF9-BDF1-4CFA-B535-0413D62BE29A}" type="datetime1">
               <a:rPr lang="en-US" smtClean="0"/>
-              <a:t>5/2/2026</a:t>
+              <a:t>5/5/2026</a:t>
             </a:fld>
             <a:endParaRPr lang="en-US" dirty="0"/>
           </a:p>
@@ -22847,7 +22445,7 @@
           <a:p>
             <a:fld id="{9DFFF819-4E26-4576-8A6D-DA055CFF682A}" type="datetime1">
               <a:rPr lang="en-US" smtClean="0"/>
-              <a:t>5/2/2026</a:t>
+              <a:t>5/5/2026</a:t>
             </a:fld>
             <a:endParaRPr lang="en-US" dirty="0"/>
           </a:p>
@@ -23511,7 +23109,7 @@
           <a:p>
             <a:fld id="{6E761A50-B070-4EAD-9EB9-92E4929324E7}" type="datetime1">
               <a:rPr lang="en-US" smtClean="0"/>
-              <a:t>5/2/2026</a:t>
+              <a:t>5/5/2026</a:t>
             </a:fld>
             <a:endParaRPr lang="en-US" dirty="0"/>
           </a:p>
@@ -23727,7 +23325,7 @@
           <a:p>
             <a:fld id="{9A1CBA35-F376-4C5F-B8C5-4C103617FD91}" type="datetime1">
               <a:rPr lang="en-US" smtClean="0"/>
-              <a:t>5/2/2026</a:t>
+              <a:t>5/5/2026</a:t>
             </a:fld>
             <a:endParaRPr lang="en-US" dirty="0"/>
           </a:p>
@@ -24397,7 +23995,7 @@
           <a:p>
             <a:fld id="{BA89D600-DCDC-4EC3-BDD3-052C2836DAF2}" type="datetime1">
               <a:rPr lang="en-US" smtClean="0"/>
-              <a:t>5/2/2026</a:t>
+              <a:t>5/5/2026</a:t>
             </a:fld>
             <a:endParaRPr lang="en-US" dirty="0"/>
           </a:p>
@@ -24923,7 +24521,7 @@
           <a:p>
             <a:fld id="{3ADB2DB3-0A08-4E5B-8BB6-A488CF1C042F}" type="datetime1">
               <a:rPr lang="en-US" smtClean="0"/>
-              <a:t>5/2/2026</a:t>
+              <a:t>5/5/2026</a:t>
             </a:fld>
             <a:endParaRPr lang="en-US" dirty="0"/>
           </a:p>
@@ -25267,7 +24865,7 @@
           <a:p>
             <a:fld id="{7A329DD1-6F17-4170-B2B1-1A76C32D62A1}" type="datetime1">
               <a:rPr lang="en-US" smtClean="0"/>
-              <a:t>5/2/2026</a:t>
+              <a:t>5/5/2026</a:t>
             </a:fld>
             <a:endParaRPr lang="en-US" dirty="0"/>
           </a:p>
@@ -25763,7 +25361,7 @@
           <a:p>
             <a:fld id="{BA7E6053-DA33-4DC9-86BB-0E52E5EB5B56}" type="datetime1">
               <a:rPr lang="en-US" smtClean="0"/>
-              <a:t>5/2/2026</a:t>
+              <a:t>5/5/2026</a:t>
             </a:fld>
             <a:endParaRPr lang="en-US" dirty="0"/>
           </a:p>
@@ -25908,7 +25506,7 @@
           <a:p>
             <a:fld id="{7C72CE4D-D83F-44D4-ACB0-A88A6B9DB4F7}" type="datetime1">
               <a:rPr lang="en-US" smtClean="0"/>
-              <a:t>5/2/2026</a:t>
+              <a:t>5/5/2026</a:t>
             </a:fld>
             <a:endParaRPr lang="en-US"/>
           </a:p>
@@ -26024,7 +25622,7 @@
           <a:p>
             <a:fld id="{9A62F981-1EE1-49F5-B605-4EA23F0307AC}" type="datetime1">
               <a:rPr lang="en-US" smtClean="0"/>
-              <a:t>5/2/2026</a:t>
+              <a:t>5/5/2026</a:t>
             </a:fld>
             <a:endParaRPr lang="en-US"/>
           </a:p>
@@ -26481,7 +26079,7 @@
           <a:p>
             <a:fld id="{B0B6493B-A447-4205-AC2D-AE2DEDAE4E3B}" type="datetime1">
               <a:rPr lang="en-US" smtClean="0"/>
-              <a:t>5/2/2026</a:t>
+              <a:t>5/5/2026</a:t>
             </a:fld>
             <a:endParaRPr lang="en-US"/>
           </a:p>
@@ -26903,7 +26501,7 @@
           <a:p>
             <a:fld id="{1F9A354F-9C13-4261-9BA4-DD76051C2429}" type="datetime1">
               <a:rPr lang="en-US" smtClean="0"/>
-              <a:t>5/2/2026</a:t>
+              <a:t>5/5/2026</a:t>
             </a:fld>
             <a:endParaRPr lang="en-US" dirty="0"/>
           </a:p>
@@ -27340,7 +26938,7 @@
           <a:p>
             <a:fld id="{2602ACF4-9E47-4D03-8EA6-1CE7E20F9165}" type="datetime1">
               <a:rPr lang="en-US" smtClean="0"/>
-              <a:t>5/2/2026</a:t>
+              <a:t>5/5/2026</a:t>
             </a:fld>
             <a:endParaRPr lang="en-US" dirty="0"/>
           </a:p>
@@ -27743,7 +27341,7 @@
           <a:p>
             <a:fld id="{D3A9CD26-23FE-488A-AF3B-5DDE99301C10}" type="datetime1">
               <a:rPr lang="en-US" smtClean="0"/>
-              <a:t>5/2/2026</a:t>
+              <a:t>5/5/2026</a:t>
             </a:fld>
             <a:endParaRPr lang="en-US" dirty="0"/>
           </a:p>
@@ -28002,7 +27600,7 @@
           <a:p>
             <a:fld id="{CC67263D-2536-4E2E-A4D6-BA89E45F00B0}" type="datetime1">
               <a:rPr lang="en-US" smtClean="0"/>
-              <a:t>5/2/2026</a:t>
+              <a:t>5/5/2026</a:t>
             </a:fld>
             <a:endParaRPr lang="en-US" dirty="0"/>
           </a:p>
@@ -28625,7 +28223,7 @@
           <a:p>
             <a:fld id="{3A82B809-8BB3-463C-8B5E-28962B4654D8}" type="datetime1">
               <a:rPr lang="en-US" smtClean="0"/>
-              <a:t>5/2/2026</a:t>
+              <a:t>5/5/2026</a:t>
             </a:fld>
             <a:endParaRPr lang="en-US" dirty="0"/>
           </a:p>
@@ -28848,7 +28446,7 @@
           <a:p>
             <a:fld id="{2DB8F537-5E0E-4697-8198-FDF0E53F372F}" type="datetime1">
               <a:rPr lang="en-US" smtClean="0"/>
-              <a:t>5/2/2026</a:t>
+              <a:t>5/5/2026</a:t>
             </a:fld>
             <a:endParaRPr lang="en-US" dirty="0"/>
           </a:p>
@@ -29342,7 +28940,7 @@
           <a:p>
             <a:fld id="{1D4E7D34-A495-4E23-B1D1-F5D651D22AFE}" type="datetime1">
               <a:rPr lang="en-US" smtClean="0"/>
-              <a:t>5/2/2026</a:t>
+              <a:t>5/5/2026</a:t>
             </a:fld>
             <a:endParaRPr lang="en-US" dirty="0"/>
           </a:p>
@@ -29525,7 +29123,7 @@
           <a:p>
             <a:fld id="{85976A96-D1F6-4A74-B023-FDE16753EDD7}" type="datetime1">
               <a:rPr lang="en-US" smtClean="0"/>
-              <a:t>5/2/2026</a:t>
+              <a:t>5/5/2026</a:t>
             </a:fld>
             <a:endParaRPr lang="en-US" dirty="0"/>
           </a:p>
@@ -29784,7 +29382,7 @@
           <a:p>
             <a:fld id="{FD1C4689-B28D-4D3C-8B05-9ABB967E2A3E}" type="datetime1">
               <a:rPr lang="en-US" smtClean="0"/>
-              <a:t>5/2/2026</a:t>
+              <a:t>5/5/2026</a:t>
             </a:fld>
             <a:endParaRPr lang="en-US" dirty="0"/>
           </a:p>
@@ -31938,10 +31536,10 @@
           <a:lstStyle/>
           <a:p>
             <a:r>
-              <a:rPr lang="en-US" sz="4200" b="1"/>
+              <a:rPr lang="en-US" sz="4200" b="1" dirty="0"/>
               <a:t>Premium Distribution (All Homes)</a:t>
             </a:r>
-            <a:endParaRPr lang="en-US" sz="4200"/>
+            <a:endParaRPr lang="en-US" sz="4200" dirty="0"/>
           </a:p>
         </p:txBody>
       </p:sp>
@@ -31976,8 +31574,8 @@
           <a:noFill/>
         </p:spPr>
       </p:pic>
-      <mc:AlternateContent xmlns:mc="http://schemas.openxmlformats.org/markup-compatibility/2006">
-        <mc:Choice xmlns:a14="http://schemas.microsoft.com/office/drawing/2010/main" Requires="a14">
+      <mc:AlternateContent xmlns:mc="http://schemas.openxmlformats.org/markup-compatibility/2006" xmlns:a14="http://schemas.microsoft.com/office/drawing/2010/main">
+        <mc:Choice Requires="a14">
           <p:sp>
             <p:nvSpPr>
               <p:cNvPr id="4" name="Content Placeholder 3">
@@ -32117,7 +31715,7 @@
             </p:txBody>
           </p:sp>
         </mc:Choice>
-        <mc:Fallback>
+        <mc:Fallback xmlns="">
           <p:sp>
             <p:nvSpPr>
               <p:cNvPr id="4" name="Content Placeholder 3">
@@ -33299,7 +32897,7 @@
                   <a:srgbClr val="0F1115"/>
                 </a:solidFill>
                 <a:effectLst/>
-                <a:latin typeface="quote-cjk-patch"/>
+                <a:latin typeface="Aptos Light (Body)"/>
               </a:rPr>
               <a:t>Statistical Test:</a:t>
             </a:r>
@@ -33309,7 +32907,7 @@
                   <a:srgbClr val="0F1115"/>
                 </a:solidFill>
                 <a:effectLst/>
-                <a:latin typeface="quote-cjk-patch"/>
+                <a:latin typeface="Aptos Light (Body)"/>
               </a:rPr>
               <a:t> Chi-square p-value = 0.585 (not significant)</a:t>
             </a:r>
@@ -33330,7 +32928,7 @@
                   <a:srgbClr val="0F1115"/>
                 </a:solidFill>
                 <a:effectLst/>
-                <a:latin typeface="quote-cjk-patch"/>
+                <a:latin typeface="Aptos Light (Body)"/>
               </a:rPr>
               <a:t>Key Finding:</a:t>
             </a:r>
@@ -33340,7 +32938,7 @@
                   <a:srgbClr val="0F1115"/>
                 </a:solidFill>
                 <a:effectLst/>
-                <a:latin typeface="quote-cjk-patch"/>
+                <a:latin typeface="Aptos Light (Body)"/>
               </a:rPr>
               <a:t> Flood zone homes do NOT file claims at a statistically higher rate despite paying 32% higher premiums</a:t>
             </a:r>

</xml_diff>

<commit_message>
Updated PDF and PowerPoint files
</commit_message>
<xml_diff>
--- a/Insurance_Management_Presentation.pptx
+++ b/Insurance_Management_Presentation.pptx
@@ -140,7 +140,7 @@
   <pc:docChgLst>
     <pc:chgData name="Tolu Atanda" userId="aaf42d42e9a9e251" providerId="LiveId" clId="{221A5667-1878-4670-971A-4761DD081DF9}"/>
     <pc:docChg chg="undo custSel addSld modSld addMainMaster delMainMaster">
-      <pc:chgData name="Tolu Atanda" userId="aaf42d42e9a9e251" providerId="LiveId" clId="{221A5667-1878-4670-971A-4761DD081DF9}" dt="2026-05-05T20:05:10.686" v="483" actId="2711"/>
+      <pc:chgData name="Tolu Atanda" userId="aaf42d42e9a9e251" providerId="LiveId" clId="{221A5667-1878-4670-971A-4761DD081DF9}" dt="2026-05-11T22:44:31.088" v="495" actId="14100"/>
       <pc:docMkLst>
         <pc:docMk/>
       </pc:docMkLst>
@@ -386,7 +386,7 @@
         </pc:picChg>
       </pc:sldChg>
       <pc:sldChg chg="addSp delSp modSp new mod chgLayout">
-        <pc:chgData name="Tolu Atanda" userId="aaf42d42e9a9e251" providerId="LiveId" clId="{221A5667-1878-4670-971A-4761DD081DF9}" dt="2026-05-03T13:15:48.319" v="435" actId="14100"/>
+        <pc:chgData name="Tolu Atanda" userId="aaf42d42e9a9e251" providerId="LiveId" clId="{221A5667-1878-4670-971A-4761DD081DF9}" dt="2026-05-11T22:44:31.088" v="495" actId="14100"/>
         <pc:sldMkLst>
           <pc:docMk/>
           <pc:sldMk cId="3142278650" sldId="263"/>
@@ -400,7 +400,7 @@
           </ac:spMkLst>
         </pc:spChg>
         <pc:spChg chg="add mod ord">
-          <ac:chgData name="Tolu Atanda" userId="aaf42d42e9a9e251" providerId="LiveId" clId="{221A5667-1878-4670-971A-4761DD081DF9}" dt="2026-05-03T13:15:25.825" v="429" actId="27636"/>
+          <ac:chgData name="Tolu Atanda" userId="aaf42d42e9a9e251" providerId="LiveId" clId="{221A5667-1878-4670-971A-4761DD081DF9}" dt="2026-05-11T22:44:13.664" v="491" actId="14100"/>
           <ac:spMkLst>
             <pc:docMk/>
             <pc:sldMk cId="3142278650" sldId="263"/>
@@ -408,7 +408,7 @@
           </ac:spMkLst>
         </pc:spChg>
         <pc:graphicFrameChg chg="add mod modGraphic">
-          <ac:chgData name="Tolu Atanda" userId="aaf42d42e9a9e251" providerId="LiveId" clId="{221A5667-1878-4670-971A-4761DD081DF9}" dt="2026-05-03T13:15:48.319" v="435" actId="14100"/>
+          <ac:chgData name="Tolu Atanda" userId="aaf42d42e9a9e251" providerId="LiveId" clId="{221A5667-1878-4670-971A-4761DD081DF9}" dt="2026-05-11T22:44:17.665" v="492" actId="14100"/>
           <ac:graphicFrameMkLst>
             <pc:docMk/>
             <pc:sldMk cId="3142278650" sldId="263"/>
@@ -416,7 +416,15 @@
           </ac:graphicFrameMkLst>
         </pc:graphicFrameChg>
         <pc:picChg chg="add mod">
-          <ac:chgData name="Tolu Atanda" userId="aaf42d42e9a9e251" providerId="LiveId" clId="{221A5667-1878-4670-971A-4761DD081DF9}" dt="2026-05-03T12:52:47.401" v="297" actId="26606"/>
+          <ac:chgData name="Tolu Atanda" userId="aaf42d42e9a9e251" providerId="LiveId" clId="{221A5667-1878-4670-971A-4761DD081DF9}" dt="2026-05-11T22:44:31.088" v="495" actId="14100"/>
+          <ac:picMkLst>
+            <pc:docMk/>
+            <pc:sldMk cId="3142278650" sldId="263"/>
+            <ac:picMk id="4" creationId="{A1072CB2-7A84-9C75-3FC7-A4836B7645B5}"/>
+          </ac:picMkLst>
+        </pc:picChg>
+        <pc:picChg chg="add del mod">
+          <ac:chgData name="Tolu Atanda" userId="aaf42d42e9a9e251" providerId="LiveId" clId="{221A5667-1878-4670-971A-4761DD081DF9}" dt="2026-05-11T22:43:16.443" v="485" actId="478"/>
           <ac:picMkLst>
             <pc:docMk/>
             <pc:sldMk cId="3142278650" sldId="263"/>
@@ -3292,13 +3300,13 @@
       <dgm:prSet presAssocID="{37607812-0775-4CE9-BA05-805A6010336A}" presName="iconRect" presStyleLbl="node1" presStyleIdx="0" presStyleCnt="4"/>
       <dgm:spPr>
         <a:blipFill>
-          <a:blip xmlns:r="http://schemas.openxmlformats.org/officeDocument/2006/relationships" r:embed="rId1">
+          <a:blip xmlns:r="http://schemas.openxmlformats.org/officeDocument/2006/relationships">
             <a:extLst>
               <a:ext uri="{28A0092B-C50C-407E-A947-70E740481C1C}">
                 <a14:useLocalDpi xmlns:a14="http://schemas.microsoft.com/office/drawing/2010/main" val="0"/>
               </a:ext>
               <a:ext uri="{96DAC541-7B7A-43D3-8B79-37D633B846F1}">
-                <asvg:svgBlip xmlns:asvg="http://schemas.microsoft.com/office/drawing/2016/SVG/main" r:embed="rId2"/>
+                <asvg:svgBlip xmlns:asvg="http://schemas.microsoft.com/office/drawing/2016/SVG/main" r:embed="rId1"/>
               </a:ext>
             </a:extLst>
           </a:blip>
@@ -3345,13 +3353,13 @@
       <dgm:prSet presAssocID="{9DD03192-1A38-4AF7-BE54-B51042123213}" presName="iconRect" presStyleLbl="node1" presStyleIdx="1" presStyleCnt="4"/>
       <dgm:spPr>
         <a:blipFill>
-          <a:blip xmlns:r="http://schemas.openxmlformats.org/officeDocument/2006/relationships" r:embed="rId3">
+          <a:blip xmlns:r="http://schemas.openxmlformats.org/officeDocument/2006/relationships">
             <a:extLst>
               <a:ext uri="{28A0092B-C50C-407E-A947-70E740481C1C}">
                 <a14:useLocalDpi xmlns:a14="http://schemas.microsoft.com/office/drawing/2010/main" val="0"/>
               </a:ext>
               <a:ext uri="{96DAC541-7B7A-43D3-8B79-37D633B846F1}">
-                <asvg:svgBlip xmlns:asvg="http://schemas.microsoft.com/office/drawing/2016/SVG/main" r:embed="rId4"/>
+                <asvg:svgBlip xmlns:asvg="http://schemas.microsoft.com/office/drawing/2016/SVG/main" r:embed="rId2"/>
               </a:ext>
             </a:extLst>
           </a:blip>
@@ -3398,13 +3406,13 @@
       <dgm:prSet presAssocID="{DC5736DE-43AE-4256-B4F0-F4DA3244E37E}" presName="iconRect" presStyleLbl="node1" presStyleIdx="2" presStyleCnt="4"/>
       <dgm:spPr>
         <a:blipFill>
-          <a:blip xmlns:r="http://schemas.openxmlformats.org/officeDocument/2006/relationships" r:embed="rId5">
+          <a:blip xmlns:r="http://schemas.openxmlformats.org/officeDocument/2006/relationships">
             <a:extLst>
               <a:ext uri="{28A0092B-C50C-407E-A947-70E740481C1C}">
                 <a14:useLocalDpi xmlns:a14="http://schemas.microsoft.com/office/drawing/2010/main" val="0"/>
               </a:ext>
               <a:ext uri="{96DAC541-7B7A-43D3-8B79-37D633B846F1}">
-                <asvg:svgBlip xmlns:asvg="http://schemas.microsoft.com/office/drawing/2016/SVG/main" r:embed="rId6"/>
+                <asvg:svgBlip xmlns:asvg="http://schemas.microsoft.com/office/drawing/2016/SVG/main" r:embed="rId3"/>
               </a:ext>
             </a:extLst>
           </a:blip>
@@ -3451,13 +3459,13 @@
       <dgm:prSet presAssocID="{CEDAD963-6429-49FB-B970-3C9F6EE87C7D}" presName="iconRect" presStyleLbl="node1" presStyleIdx="3" presStyleCnt="4"/>
       <dgm:spPr>
         <a:blipFill>
-          <a:blip xmlns:r="http://schemas.openxmlformats.org/officeDocument/2006/relationships" r:embed="rId7">
+          <a:blip xmlns:r="http://schemas.openxmlformats.org/officeDocument/2006/relationships">
             <a:extLst>
               <a:ext uri="{28A0092B-C50C-407E-A947-70E740481C1C}">
                 <a14:useLocalDpi xmlns:a14="http://schemas.microsoft.com/office/drawing/2010/main" val="0"/>
               </a:ext>
               <a:ext uri="{96DAC541-7B7A-43D3-8B79-37D633B846F1}">
-                <asvg:svgBlip xmlns:asvg="http://schemas.microsoft.com/office/drawing/2016/SVG/main" r:embed="rId8"/>
+                <asvg:svgBlip xmlns:asvg="http://schemas.microsoft.com/office/drawing/2016/SVG/main" r:embed="rId4"/>
               </a:ext>
             </a:extLst>
           </a:blip>
@@ -4498,13 +4506,13 @@
           <a:avLst/>
         </a:prstGeom>
         <a:blipFill>
-          <a:blip xmlns:r="http://schemas.openxmlformats.org/officeDocument/2006/relationships" r:embed="rId1">
+          <a:blip xmlns:r="http://schemas.openxmlformats.org/officeDocument/2006/relationships">
             <a:extLst>
               <a:ext uri="{28A0092B-C50C-407E-A947-70E740481C1C}">
                 <a14:useLocalDpi xmlns:a14="http://schemas.microsoft.com/office/drawing/2010/main" val="0"/>
               </a:ext>
               <a:ext uri="{96DAC541-7B7A-43D3-8B79-37D633B846F1}">
-                <asvg:svgBlip xmlns:asvg="http://schemas.microsoft.com/office/drawing/2016/SVG/main" r:embed="rId2"/>
+                <asvg:svgBlip xmlns:asvg="http://schemas.microsoft.com/office/drawing/2016/SVG/main" r:embed="rId1"/>
               </a:ext>
             </a:extLst>
           </a:blip>
@@ -4654,13 +4662,13 @@
           <a:avLst/>
         </a:prstGeom>
         <a:blipFill>
-          <a:blip xmlns:r="http://schemas.openxmlformats.org/officeDocument/2006/relationships" r:embed="rId3">
+          <a:blip xmlns:r="http://schemas.openxmlformats.org/officeDocument/2006/relationships">
             <a:extLst>
               <a:ext uri="{28A0092B-C50C-407E-A947-70E740481C1C}">
                 <a14:useLocalDpi xmlns:a14="http://schemas.microsoft.com/office/drawing/2010/main" val="0"/>
               </a:ext>
               <a:ext uri="{96DAC541-7B7A-43D3-8B79-37D633B846F1}">
-                <asvg:svgBlip xmlns:asvg="http://schemas.microsoft.com/office/drawing/2016/SVG/main" r:embed="rId4"/>
+                <asvg:svgBlip xmlns:asvg="http://schemas.microsoft.com/office/drawing/2016/SVG/main" r:embed="rId2"/>
               </a:ext>
             </a:extLst>
           </a:blip>
@@ -4810,13 +4818,13 @@
           <a:avLst/>
         </a:prstGeom>
         <a:blipFill>
-          <a:blip xmlns:r="http://schemas.openxmlformats.org/officeDocument/2006/relationships" r:embed="rId5">
+          <a:blip xmlns:r="http://schemas.openxmlformats.org/officeDocument/2006/relationships">
             <a:extLst>
               <a:ext uri="{28A0092B-C50C-407E-A947-70E740481C1C}">
                 <a14:useLocalDpi xmlns:a14="http://schemas.microsoft.com/office/drawing/2010/main" val="0"/>
               </a:ext>
               <a:ext uri="{96DAC541-7B7A-43D3-8B79-37D633B846F1}">
-                <asvg:svgBlip xmlns:asvg="http://schemas.microsoft.com/office/drawing/2016/SVG/main" r:embed="rId6"/>
+                <asvg:svgBlip xmlns:asvg="http://schemas.microsoft.com/office/drawing/2016/SVG/main" r:embed="rId3"/>
               </a:ext>
             </a:extLst>
           </a:blip>
@@ -4966,13 +4974,13 @@
           <a:avLst/>
         </a:prstGeom>
         <a:blipFill>
-          <a:blip xmlns:r="http://schemas.openxmlformats.org/officeDocument/2006/relationships" r:embed="rId7">
+          <a:blip xmlns:r="http://schemas.openxmlformats.org/officeDocument/2006/relationships">
             <a:extLst>
               <a:ext uri="{28A0092B-C50C-407E-A947-70E740481C1C}">
                 <a14:useLocalDpi xmlns:a14="http://schemas.microsoft.com/office/drawing/2010/main" val="0"/>
               </a:ext>
               <a:ext uri="{96DAC541-7B7A-43D3-8B79-37D633B846F1}">
-                <asvg:svgBlip xmlns:asvg="http://schemas.microsoft.com/office/drawing/2016/SVG/main" r:embed="rId8"/>
+                <asvg:svgBlip xmlns:asvg="http://schemas.microsoft.com/office/drawing/2016/SVG/main" r:embed="rId4"/>
               </a:ext>
             </a:extLst>
           </a:blip>
@@ -8323,7 +8331,7 @@
           <a:p>
             <a:fld id="{D29CF56E-D922-4450-9794-8B0E1451F6EB}" type="datetime1">
               <a:rPr lang="en-US" smtClean="0"/>
-              <a:t>5/5/2026</a:t>
+              <a:t>5/11/2026</a:t>
             </a:fld>
             <a:endParaRPr lang="en-US" dirty="0"/>
           </a:p>
@@ -8900,7 +8908,7 @@
           <a:p>
             <a:fld id="{9C5C1F80-0989-4135-BEC0-53996BCA1D73}" type="datetime1">
               <a:rPr lang="en-US" smtClean="0"/>
-              <a:t>5/5/2026</a:t>
+              <a:t>5/11/2026</a:t>
             </a:fld>
             <a:endParaRPr lang="en-US" dirty="0"/>
           </a:p>
@@ -9458,7 +9466,7 @@
           <a:p>
             <a:fld id="{2B346B3B-D23C-46FC-82B4-EC936862EBB6}" type="datetime1">
               <a:rPr lang="en-US" smtClean="0"/>
-              <a:t>5/5/2026</a:t>
+              <a:t>5/11/2026</a:t>
             </a:fld>
             <a:endParaRPr lang="en-US" dirty="0"/>
           </a:p>
@@ -9988,7 +9996,7 @@
           <a:p>
             <a:fld id="{11039C6F-01AE-405F-93D2-431591D79461}" type="datetime1">
               <a:rPr lang="en-US" smtClean="0"/>
-              <a:t>5/5/2026</a:t>
+              <a:t>5/11/2026</a:t>
             </a:fld>
             <a:endParaRPr lang="en-US" dirty="0"/>
           </a:p>
@@ -10391,7 +10399,7 @@
           <a:p>
             <a:fld id="{6AE82713-2685-4CB9-BD26-DD329F3C67A6}" type="datetime1">
               <a:rPr lang="en-US" smtClean="0"/>
-              <a:t>5/5/2026</a:t>
+              <a:t>5/11/2026</a:t>
             </a:fld>
             <a:endParaRPr lang="en-US" dirty="0"/>
           </a:p>
@@ -10790,7 +10798,7 @@
           <a:p>
             <a:fld id="{957926B3-CA5D-44FB-BC2D-6B05FBB97B04}" type="datetime1">
               <a:rPr lang="en-US" smtClean="0"/>
-              <a:t>5/5/2026</a:t>
+              <a:t>5/11/2026</a:t>
             </a:fld>
             <a:endParaRPr lang="en-US" dirty="0"/>
           </a:p>
@@ -11188,7 +11196,7 @@
           <a:p>
             <a:fld id="{7E009212-C305-41EC-8687-C39B36C09AF0}" type="datetime1">
               <a:rPr lang="en-US" smtClean="0"/>
-              <a:t>5/5/2026</a:t>
+              <a:t>5/11/2026</a:t>
             </a:fld>
             <a:endParaRPr lang="en-US" dirty="0"/>
           </a:p>
@@ -11587,7 +11595,7 @@
           <a:p>
             <a:fld id="{7CD886C8-FB0E-44DB-9413-26C9933623BA}" type="datetime1">
               <a:rPr lang="en-US" smtClean="0"/>
-              <a:t>5/5/2026</a:t>
+              <a:t>5/11/2026</a:t>
             </a:fld>
             <a:endParaRPr lang="en-US" dirty="0"/>
           </a:p>
@@ -11987,7 +11995,7 @@
           <a:p>
             <a:fld id="{278A6864-E7E2-494F-A90A-ECC53613C6EC}" type="datetime1">
               <a:rPr lang="en-US" smtClean="0"/>
-              <a:t>5/5/2026</a:t>
+              <a:t>5/11/2026</a:t>
             </a:fld>
             <a:endParaRPr lang="en-US" dirty="0"/>
           </a:p>
@@ -12354,7 +12362,7 @@
           <a:p>
             <a:fld id="{2F4ED686-7864-484B-8047-F06E855FD995}" type="datetime1">
               <a:rPr lang="en-US" smtClean="0"/>
-              <a:t>5/5/2026</a:t>
+              <a:t>5/11/2026</a:t>
             </a:fld>
             <a:endParaRPr lang="en-US" dirty="0"/>
           </a:p>
@@ -12735,7 +12743,7 @@
           <a:p>
             <a:fld id="{CB8F8C76-8E31-4D47-BC79-85F35E81929B}" type="datetime1">
               <a:rPr lang="en-US" smtClean="0"/>
-              <a:t>5/5/2026</a:t>
+              <a:t>5/11/2026</a:t>
             </a:fld>
             <a:endParaRPr lang="en-US" dirty="0"/>
           </a:p>
@@ -13114,7 +13122,7 @@
           <a:p>
             <a:fld id="{CBE1C96F-46D7-47BB-8945-9667BCB4F5BB}" type="datetime1">
               <a:rPr lang="en-US" smtClean="0"/>
-              <a:t>5/5/2026</a:t>
+              <a:t>5/11/2026</a:t>
             </a:fld>
             <a:endParaRPr lang="en-US" dirty="0"/>
           </a:p>
@@ -13547,7 +13555,7 @@
           <a:p>
             <a:fld id="{85640267-1344-46BE-B105-162E68855468}" type="datetime1">
               <a:rPr lang="en-US" smtClean="0"/>
-              <a:t>5/5/2026</a:t>
+              <a:t>5/11/2026</a:t>
             </a:fld>
             <a:endParaRPr lang="en-US" dirty="0"/>
           </a:p>
@@ -13964,7 +13972,7 @@
           <a:p>
             <a:fld id="{1C45E567-307A-4358-87B7-AFD16C4C07D5}" type="datetime1">
               <a:rPr lang="en-US" smtClean="0"/>
-              <a:t>5/5/2026</a:t>
+              <a:t>5/11/2026</a:t>
             </a:fld>
             <a:endParaRPr lang="en-US" dirty="0"/>
           </a:p>
@@ -14182,7 +14190,7 @@
           <a:p>
             <a:fld id="{E016730A-3443-4D7F-BC47-3A3CDB3837FC}" type="datetime1">
               <a:rPr lang="en-US" smtClean="0"/>
-              <a:t>5/5/2026</a:t>
+              <a:t>5/11/2026</a:t>
             </a:fld>
             <a:endParaRPr lang="en-US" dirty="0"/>
           </a:p>
@@ -14799,7 +14807,7 @@
           <a:p>
             <a:fld id="{D9193AC5-F257-4C01-8A7B-A4CD87F22F04}" type="datetime1">
               <a:rPr lang="en-US" smtClean="0"/>
-              <a:t>5/5/2026</a:t>
+              <a:t>5/11/2026</a:t>
             </a:fld>
             <a:endParaRPr lang="en-US" dirty="0"/>
           </a:p>
@@ -15170,7 +15178,7 @@
           <a:p>
             <a:fld id="{A64EBB10-E93E-4729-97C4-FAB8DF4548E2}" type="datetime1">
               <a:rPr lang="en-US" smtClean="0"/>
-              <a:t>5/5/2026</a:t>
+              <a:t>5/11/2026</a:t>
             </a:fld>
             <a:endParaRPr lang="en-US" dirty="0"/>
           </a:p>
@@ -15443,7 +15451,7 @@
           <a:p>
             <a:fld id="{7040DD2C-7FC6-41A9-87A2-29E4EDD4A815}" type="datetime1">
               <a:rPr lang="en-US" smtClean="0"/>
-              <a:t>5/5/2026</a:t>
+              <a:t>5/11/2026</a:t>
             </a:fld>
             <a:endParaRPr lang="en-US" dirty="0"/>
           </a:p>
@@ -16068,7 +16076,7 @@
           <a:p>
             <a:fld id="{C8E3A8ED-7C53-48B7-8E07-F767A8357B67}" type="datetime1">
               <a:rPr lang="en-US" smtClean="0"/>
-              <a:t>5/5/2026</a:t>
+              <a:t>5/11/2026</a:t>
             </a:fld>
             <a:endParaRPr lang="en-US" dirty="0"/>
           </a:p>
@@ -16503,7 +16511,7 @@
           <a:p>
             <a:fld id="{81AC3B39-0D1D-4C0E-BE8E-C570B18D6B3B}" type="datetime1">
               <a:rPr lang="en-US" smtClean="0"/>
-              <a:t>5/5/2026</a:t>
+              <a:t>5/11/2026</a:t>
             </a:fld>
             <a:endParaRPr lang="en-US" dirty="0"/>
           </a:p>
@@ -16752,7 +16760,7 @@
           <a:p>
             <a:fld id="{0780F3AB-C899-4854-A4A4-B2E20F203358}" type="datetime1">
               <a:rPr lang="en-US" smtClean="0"/>
-              <a:t>5/5/2026</a:t>
+              <a:t>5/11/2026</a:t>
             </a:fld>
             <a:endParaRPr lang="en-US" dirty="0"/>
           </a:p>
@@ -17392,7 +17400,7 @@
           <a:p>
             <a:fld id="{1095A040-388D-41D5-A09F-3EC1A1D097A8}" type="datetime1">
               <a:rPr lang="en-US" smtClean="0"/>
-              <a:t>5/5/2026</a:t>
+              <a:t>5/11/2026</a:t>
             </a:fld>
             <a:endParaRPr lang="en-US" dirty="0"/>
           </a:p>
@@ -17812,7 +17820,7 @@
           <a:p>
             <a:fld id="{A6379DD5-AE65-4D02-9BCE-257CC17A63B7}" type="datetime1">
               <a:rPr lang="en-US" smtClean="0"/>
-              <a:t>5/5/2026</a:t>
+              <a:t>5/11/2026</a:t>
             </a:fld>
             <a:endParaRPr lang="en-US" dirty="0"/>
           </a:p>
@@ -18254,7 +18262,7 @@
           <a:p>
             <a:fld id="{5ECB542C-378A-4AAF-83EE-A3767FF83605}" type="datetime1">
               <a:rPr lang="en-US" smtClean="0"/>
-              <a:t>5/5/2026</a:t>
+              <a:t>5/11/2026</a:t>
             </a:fld>
             <a:endParaRPr lang="en-US"/>
           </a:p>
@@ -18546,7 +18554,7 @@
           <a:p>
             <a:fld id="{16C6F251-EB74-4ADA-AD63-D85EC3A9D616}" type="datetime1">
               <a:rPr lang="en-US" smtClean="0"/>
-              <a:t>5/5/2026</a:t>
+              <a:t>5/11/2026</a:t>
             </a:fld>
             <a:endParaRPr lang="en-US" dirty="0"/>
           </a:p>
@@ -18954,7 +18962,7 @@
           <a:p>
             <a:fld id="{7305F46D-792E-48B7-9047-8A1672515077}" type="datetime1">
               <a:rPr lang="en-US" smtClean="0"/>
-              <a:t>5/5/2026</a:t>
+              <a:t>5/11/2026</a:t>
             </a:fld>
             <a:endParaRPr lang="en-US" dirty="0"/>
           </a:p>
@@ -19362,7 +19370,7 @@
           <a:p>
             <a:fld id="{8B53D3FE-D727-4B50-874D-41D5E635B20A}" type="datetime1">
               <a:rPr lang="en-US" smtClean="0"/>
-              <a:t>5/5/2026</a:t>
+              <a:t>5/11/2026</a:t>
             </a:fld>
             <a:endParaRPr lang="en-US" dirty="0"/>
           </a:p>
@@ -19770,7 +19778,7 @@
           <a:p>
             <a:fld id="{FE942071-3A2D-4B86-82F9-428DB212BAF8}" type="datetime1">
               <a:rPr lang="en-US" smtClean="0"/>
-              <a:t>5/5/2026</a:t>
+              <a:t>5/11/2026</a:t>
             </a:fld>
             <a:endParaRPr lang="en-US" dirty="0"/>
           </a:p>
@@ -20451,7 +20459,7 @@
           <a:p>
             <a:fld id="{040D1012-6B36-4753-8153-E5F982239567}" type="datetime1">
               <a:rPr lang="en-US" smtClean="0"/>
-              <a:t>5/5/2026</a:t>
+              <a:t>5/11/2026</a:t>
             </a:fld>
             <a:endParaRPr lang="en-US" dirty="0"/>
           </a:p>
@@ -20644,7 +20652,7 @@
           <a:p>
             <a:fld id="{02E2BBBB-FE25-456C-89E4-A0303F0273E5}" type="datetime1">
               <a:rPr lang="en-US" smtClean="0"/>
-              <a:t>5/5/2026</a:t>
+              <a:t>5/11/2026</a:t>
             </a:fld>
             <a:endParaRPr lang="en-US" dirty="0"/>
           </a:p>
@@ -20861,7 +20869,7 @@
           <a:p>
             <a:fld id="{1315EE4B-219D-4799-AB8D-57B100451C5D}" type="datetime1">
               <a:rPr lang="en-US" smtClean="0"/>
-              <a:t>5/5/2026</a:t>
+              <a:t>5/11/2026</a:t>
             </a:fld>
             <a:endParaRPr lang="en-US" dirty="0"/>
           </a:p>
@@ -21201,7 +21209,7 @@
           <a:p>
             <a:fld id="{6499AFF4-C109-45E7-87CB-3A41EC6C3342}" type="datetime1">
               <a:rPr lang="en-US" smtClean="0"/>
-              <a:t>5/5/2026</a:t>
+              <a:t>5/11/2026</a:t>
             </a:fld>
             <a:endParaRPr lang="en-US" dirty="0"/>
           </a:p>
@@ -22216,7 +22224,7 @@
           <a:p>
             <a:fld id="{50AFEFF9-BDF1-4CFA-B535-0413D62BE29A}" type="datetime1">
               <a:rPr lang="en-US" smtClean="0"/>
-              <a:t>5/5/2026</a:t>
+              <a:t>5/11/2026</a:t>
             </a:fld>
             <a:endParaRPr lang="en-US" dirty="0"/>
           </a:p>
@@ -22445,7 +22453,7 @@
           <a:p>
             <a:fld id="{9DFFF819-4E26-4576-8A6D-DA055CFF682A}" type="datetime1">
               <a:rPr lang="en-US" smtClean="0"/>
-              <a:t>5/5/2026</a:t>
+              <a:t>5/11/2026</a:t>
             </a:fld>
             <a:endParaRPr lang="en-US" dirty="0"/>
           </a:p>
@@ -23109,7 +23117,7 @@
           <a:p>
             <a:fld id="{6E761A50-B070-4EAD-9EB9-92E4929324E7}" type="datetime1">
               <a:rPr lang="en-US" smtClean="0"/>
-              <a:t>5/5/2026</a:t>
+              <a:t>5/11/2026</a:t>
             </a:fld>
             <a:endParaRPr lang="en-US" dirty="0"/>
           </a:p>
@@ -23325,7 +23333,7 @@
           <a:p>
             <a:fld id="{9A1CBA35-F376-4C5F-B8C5-4C103617FD91}" type="datetime1">
               <a:rPr lang="en-US" smtClean="0"/>
-              <a:t>5/5/2026</a:t>
+              <a:t>5/11/2026</a:t>
             </a:fld>
             <a:endParaRPr lang="en-US" dirty="0"/>
           </a:p>
@@ -23995,7 +24003,7 @@
           <a:p>
             <a:fld id="{BA89D600-DCDC-4EC3-BDD3-052C2836DAF2}" type="datetime1">
               <a:rPr lang="en-US" smtClean="0"/>
-              <a:t>5/5/2026</a:t>
+              <a:t>5/11/2026</a:t>
             </a:fld>
             <a:endParaRPr lang="en-US" dirty="0"/>
           </a:p>
@@ -24521,7 +24529,7 @@
           <a:p>
             <a:fld id="{3ADB2DB3-0A08-4E5B-8BB6-A488CF1C042F}" type="datetime1">
               <a:rPr lang="en-US" smtClean="0"/>
-              <a:t>5/5/2026</a:t>
+              <a:t>5/11/2026</a:t>
             </a:fld>
             <a:endParaRPr lang="en-US" dirty="0"/>
           </a:p>
@@ -24865,7 +24873,7 @@
           <a:p>
             <a:fld id="{7A329DD1-6F17-4170-B2B1-1A76C32D62A1}" type="datetime1">
               <a:rPr lang="en-US" smtClean="0"/>
-              <a:t>5/5/2026</a:t>
+              <a:t>5/11/2026</a:t>
             </a:fld>
             <a:endParaRPr lang="en-US" dirty="0"/>
           </a:p>
@@ -25361,7 +25369,7 @@
           <a:p>
             <a:fld id="{BA7E6053-DA33-4DC9-86BB-0E52E5EB5B56}" type="datetime1">
               <a:rPr lang="en-US" smtClean="0"/>
-              <a:t>5/5/2026</a:t>
+              <a:t>5/11/2026</a:t>
             </a:fld>
             <a:endParaRPr lang="en-US" dirty="0"/>
           </a:p>
@@ -25506,7 +25514,7 @@
           <a:p>
             <a:fld id="{7C72CE4D-D83F-44D4-ACB0-A88A6B9DB4F7}" type="datetime1">
               <a:rPr lang="en-US" smtClean="0"/>
-              <a:t>5/5/2026</a:t>
+              <a:t>5/11/2026</a:t>
             </a:fld>
             <a:endParaRPr lang="en-US"/>
           </a:p>
@@ -25622,7 +25630,7 @@
           <a:p>
             <a:fld id="{9A62F981-1EE1-49F5-B605-4EA23F0307AC}" type="datetime1">
               <a:rPr lang="en-US" smtClean="0"/>
-              <a:t>5/5/2026</a:t>
+              <a:t>5/11/2026</a:t>
             </a:fld>
             <a:endParaRPr lang="en-US"/>
           </a:p>
@@ -26079,7 +26087,7 @@
           <a:p>
             <a:fld id="{B0B6493B-A447-4205-AC2D-AE2DEDAE4E3B}" type="datetime1">
               <a:rPr lang="en-US" smtClean="0"/>
-              <a:t>5/5/2026</a:t>
+              <a:t>5/11/2026</a:t>
             </a:fld>
             <a:endParaRPr lang="en-US"/>
           </a:p>
@@ -26501,7 +26509,7 @@
           <a:p>
             <a:fld id="{1F9A354F-9C13-4261-9BA4-DD76051C2429}" type="datetime1">
               <a:rPr lang="en-US" smtClean="0"/>
-              <a:t>5/5/2026</a:t>
+              <a:t>5/11/2026</a:t>
             </a:fld>
             <a:endParaRPr lang="en-US" dirty="0"/>
           </a:p>
@@ -26938,7 +26946,7 @@
           <a:p>
             <a:fld id="{2602ACF4-9E47-4D03-8EA6-1CE7E20F9165}" type="datetime1">
               <a:rPr lang="en-US" smtClean="0"/>
-              <a:t>5/5/2026</a:t>
+              <a:t>5/11/2026</a:t>
             </a:fld>
             <a:endParaRPr lang="en-US" dirty="0"/>
           </a:p>
@@ -27341,7 +27349,7 @@
           <a:p>
             <a:fld id="{D3A9CD26-23FE-488A-AF3B-5DDE99301C10}" type="datetime1">
               <a:rPr lang="en-US" smtClean="0"/>
-              <a:t>5/5/2026</a:t>
+              <a:t>5/11/2026</a:t>
             </a:fld>
             <a:endParaRPr lang="en-US" dirty="0"/>
           </a:p>
@@ -27600,7 +27608,7 @@
           <a:p>
             <a:fld id="{CC67263D-2536-4E2E-A4D6-BA89E45F00B0}" type="datetime1">
               <a:rPr lang="en-US" smtClean="0"/>
-              <a:t>5/5/2026</a:t>
+              <a:t>5/11/2026</a:t>
             </a:fld>
             <a:endParaRPr lang="en-US" dirty="0"/>
           </a:p>
@@ -28223,7 +28231,7 @@
           <a:p>
             <a:fld id="{3A82B809-8BB3-463C-8B5E-28962B4654D8}" type="datetime1">
               <a:rPr lang="en-US" smtClean="0"/>
-              <a:t>5/5/2026</a:t>
+              <a:t>5/11/2026</a:t>
             </a:fld>
             <a:endParaRPr lang="en-US" dirty="0"/>
           </a:p>
@@ -28446,7 +28454,7 @@
           <a:p>
             <a:fld id="{2DB8F537-5E0E-4697-8198-FDF0E53F372F}" type="datetime1">
               <a:rPr lang="en-US" smtClean="0"/>
-              <a:t>5/5/2026</a:t>
+              <a:t>5/11/2026</a:t>
             </a:fld>
             <a:endParaRPr lang="en-US" dirty="0"/>
           </a:p>
@@ -28940,7 +28948,7 @@
           <a:p>
             <a:fld id="{1D4E7D34-A495-4E23-B1D1-F5D651D22AFE}" type="datetime1">
               <a:rPr lang="en-US" smtClean="0"/>
-              <a:t>5/5/2026</a:t>
+              <a:t>5/11/2026</a:t>
             </a:fld>
             <a:endParaRPr lang="en-US" dirty="0"/>
           </a:p>
@@ -29123,7 +29131,7 @@
           <a:p>
             <a:fld id="{85976A96-D1F6-4A74-B023-FDE16753EDD7}" type="datetime1">
               <a:rPr lang="en-US" smtClean="0"/>
-              <a:t>5/5/2026</a:t>
+              <a:t>5/11/2026</a:t>
             </a:fld>
             <a:endParaRPr lang="en-US" dirty="0"/>
           </a:p>
@@ -29382,7 +29390,7 @@
           <a:p>
             <a:fld id="{FD1C4689-B28D-4D3C-8B05-9ABB967E2A3E}" type="datetime1">
               <a:rPr lang="en-US" smtClean="0"/>
-              <a:t>5/5/2026</a:t>
+              <a:t>5/11/2026</a:t>
             </a:fld>
             <a:endParaRPr lang="en-US" dirty="0"/>
           </a:p>
@@ -33056,38 +33064,6 @@
           </a:p>
         </p:txBody>
       </p:sp>
-      <p:pic>
-        <p:nvPicPr>
-          <p:cNvPr id="8" name="Picture 7">
-            <a:extLst>
-              <a:ext uri="{FF2B5EF4-FFF2-40B4-BE49-F238E27FC236}">
-                <a16:creationId xmlns:a16="http://schemas.microsoft.com/office/drawing/2014/main" id="{B5D9EB81-9D42-3213-C3E7-5BFC474A91DC}"/>
-              </a:ext>
-            </a:extLst>
-          </p:cNvPr>
-          <p:cNvPicPr>
-            <a:picLocks noChangeAspect="1"/>
-          </p:cNvPicPr>
-          <p:nvPr/>
-        </p:nvPicPr>
-        <p:blipFill>
-          <a:blip r:embed="rId2"/>
-          <a:srcRect l="14094" r="14866"/>
-          <a:stretch>
-            <a:fillRect/>
-          </a:stretch>
-        </p:blipFill>
-        <p:spPr>
-          <a:xfrm>
-            <a:off x="119307" y="10"/>
-            <a:ext cx="5413248" cy="6857990"/>
-          </a:xfrm>
-          <a:prstGeom prst="rect">
-            <a:avLst/>
-          </a:prstGeom>
-          <a:noFill/>
-        </p:spPr>
-      </p:pic>
       <p:sp>
         <p:nvSpPr>
           <p:cNvPr id="7" name="TextBox 6">
@@ -33102,8 +33078,8 @@
         </p:nvSpPr>
         <p:spPr>
           <a:xfrm>
-            <a:off x="6272784" y="5064368"/>
-            <a:ext cx="5138928" cy="769503"/>
+            <a:off x="6630650" y="5064368"/>
+            <a:ext cx="4781061" cy="769503"/>
           </a:xfrm>
           <a:prstGeom prst="rect">
             <a:avLst/>
@@ -33154,35 +33130,35 @@
           <p:nvPr>
             <p:extLst>
               <p:ext uri="{D42A27DB-BD31-4B8C-83A1-F6EECF244321}">
-                <p14:modId xmlns:p14="http://schemas.microsoft.com/office/powerpoint/2010/main" val="3348112265"/>
+                <p14:modId xmlns:p14="http://schemas.microsoft.com/office/powerpoint/2010/main" val="1267994442"/>
               </p:ext>
             </p:extLst>
           </p:nvPr>
         </p:nvGraphicFramePr>
         <p:xfrm>
-          <a:off x="6095999" y="2304288"/>
-          <a:ext cx="5138928" cy="2184948"/>
+          <a:off x="6630650" y="2413416"/>
+          <a:ext cx="4604276" cy="1903752"/>
         </p:xfrm>
         <a:graphic>
           <a:graphicData uri="http://schemas.openxmlformats.org/drawingml/2006/table">
             <a:tbl>
               <a:tblPr/>
               <a:tblGrid>
-                <a:gridCol w="1543494">
+                <a:gridCol w="1382909">
                   <a:extLst>
                     <a:ext uri="{9D8B030D-6E8A-4147-A177-3AD203B41FA5}">
                       <a16:colId xmlns:a16="http://schemas.microsoft.com/office/drawing/2014/main" val="823762641"/>
                     </a:ext>
                   </a:extLst>
                 </a:gridCol>
-                <a:gridCol w="1434542">
+                <a:gridCol w="1285293">
                   <a:extLst>
                     <a:ext uri="{9D8B030D-6E8A-4147-A177-3AD203B41FA5}">
                       <a16:colId xmlns:a16="http://schemas.microsoft.com/office/drawing/2014/main" val="3334871533"/>
                     </a:ext>
                   </a:extLst>
                 </a:gridCol>
-                <a:gridCol w="2160892">
+                <a:gridCol w="1936074">
                   <a:extLst>
                     <a:ext uri="{9D8B030D-6E8A-4147-A177-3AD203B41FA5}">
                       <a16:colId xmlns:a16="http://schemas.microsoft.com/office/drawing/2014/main" val="201415446"/>
@@ -33190,7 +33166,7 @@
                   </a:extLst>
                 </a:gridCol>
               </a:tblGrid>
-              <a:tr h="364158">
+              <a:tr h="317292">
                 <a:tc gridSpan="3">
                   <a:txBody>
                     <a:bodyPr/>
@@ -33277,7 +33253,7 @@
                   </a:ext>
                 </a:extLst>
               </a:tr>
-              <a:tr h="364158">
+              <a:tr h="317292">
                 <a:tc>
                   <a:txBody>
                     <a:bodyPr/>
@@ -33287,7 +33263,7 @@
                         <a:buNone/>
                       </a:pPr>
                       <a:r>
-                        <a:rPr lang="en-US" sz="1100" b="1" i="0" u="none" strike="noStrike">
+                        <a:rPr lang="en-US" sz="1100" b="1" i="0" u="none" strike="noStrike" dirty="0">
                           <a:solidFill>
                             <a:srgbClr val="000000"/>
                           </a:solidFill>
@@ -33464,7 +33440,7 @@
                   </a:ext>
                 </a:extLst>
               </a:tr>
-              <a:tr h="364158">
+              <a:tr h="317292">
                 <a:tc>
                   <a:txBody>
                     <a:bodyPr/>
@@ -33651,7 +33627,7 @@
                   </a:ext>
                 </a:extLst>
               </a:tr>
-              <a:tr h="364158">
+              <a:tr h="317292">
                 <a:tc>
                   <a:txBody>
                     <a:bodyPr/>
@@ -33838,7 +33814,7 @@
                   </a:ext>
                 </a:extLst>
               </a:tr>
-              <a:tr h="364158">
+              <a:tr h="317292">
                 <a:tc>
                   <a:txBody>
                     <a:bodyPr/>
@@ -34025,7 +34001,7 @@
                   </a:ext>
                 </a:extLst>
               </a:tr>
-              <a:tr h="364158">
+              <a:tr h="317292">
                 <a:tc>
                   <a:txBody>
                     <a:bodyPr/>
@@ -34216,6 +34192,36 @@
           </a:graphicData>
         </a:graphic>
       </p:graphicFrame>
+      <p:pic>
+        <p:nvPicPr>
+          <p:cNvPr id="4" name="Picture 3">
+            <a:extLst>
+              <a:ext uri="{FF2B5EF4-FFF2-40B4-BE49-F238E27FC236}">
+                <a16:creationId xmlns:a16="http://schemas.microsoft.com/office/drawing/2014/main" id="{A1072CB2-7A84-9C75-3FC7-A4836B7645B5}"/>
+              </a:ext>
+            </a:extLst>
+          </p:cNvPr>
+          <p:cNvPicPr>
+            <a:picLocks noChangeAspect="1"/>
+          </p:cNvPicPr>
+          <p:nvPr/>
+        </p:nvPicPr>
+        <p:blipFill>
+          <a:blip r:embed="rId2"/>
+          <a:stretch>
+            <a:fillRect/>
+          </a:stretch>
+        </p:blipFill>
+        <p:spPr>
+          <a:xfrm>
+            <a:off x="292307" y="817338"/>
+            <a:ext cx="5980475" cy="5382428"/>
+          </a:xfrm>
+          <a:prstGeom prst="rect">
+            <a:avLst/>
+          </a:prstGeom>
+        </p:spPr>
+      </p:pic>
     </p:spTree>
     <p:extLst>
       <p:ext uri="{BB962C8B-B14F-4D97-AF65-F5344CB8AC3E}">

</xml_diff>